<commit_message>
docs: update the WG1 gross-price pitch to update 4 of #163
</commit_message>
<xml_diff>
--- a/docs/CEN-TC434-WG1_2026_SvanteSchubert_Gross-Prices_EN.pptx
+++ b/docs/CEN-TC434-WG1_2026_SvanteSchubert_Gross-Prices_EN.pptx
@@ -26,6 +26,7 @@
     <p:sldId id="335" r:id="rId31"/>
     <p:sldId id="347" r:id="rId62"/>
     <p:sldId id="342" r:id="rId57"/>
+    <p:sldId id="348" r:id="rId36"/>
     <p:sldId id="343" r:id="rId58"/>
     <p:sldId id="334" r:id="rId38"/>
   </p:sldIdLst>
@@ -327,7 +328,7 @@
           <a:lstStyle/>
           <a:p>
             <a:r>
-              <a:t>WG1 session on the two amendment proposals: #164 'Gross price model' and #163 'Round only once'. Goal: two decisions — the gross model in the core, and no forced rounding of intermediate values. The deck starts with what we agree on and with the legal requirements, shows why today's specification cannot meet them for gross prices, and ends with the impact on existing implementations and the decisions.</a:t>
+              <a:t>WG1 session on the two amendment proposals: #164 'Gross price model' and #163 'Round only once'. Goal: two decisions — the gross model in the core, and no forced rounding of intermediate values. The deck starts with what we agree on — in the end, accurate data — and with the legal requirements, shows why today's specification cannot meet them for gross prices, and ends with the impact on existing implementations, where the discussion stands and the decisions.</a:t>
             </a:r>
           </a:p>
         </p:txBody>
@@ -401,7 +402,7 @@
           <a:lstStyle/>
           <a:p>
             <a:r>
-              <a:t>Start with the common ground. Paul Simons (#163): 'Accounting is 100% correct or it is not.' Cyrille Sautereau (#164): his point is 'not to force companies' to give up revenue because of rounding; he cites more than 5 million companies exchanging e-invoices in France and 1.2 million in Belgium. Both goals — correct VAT and working software — are compatible: removing a maximum is not a new minimum, and the gross model is an additional, optional path.</a:t>
+              <a:t>Start with the common ground: in the end, we all want accurate data that the seller, the buyer and the tax authority can trust. Paul Simons (#163): 'Accounting is 100% correct or it is not.' Cyrille Sautereau (#164): his point is 'not to force companies' to give up revenue because of rounding; he cites more than 5 million companies exchanging e-invoices in France and 1.2 million in Belgium. Both goals — correct VAT and working software — are compatible: removing a maximum is not a new minimum, so every invoice that is conformant today stays conformant, and the gross model is an additional, optional path.</a:t>
             </a:r>
           </a:p>
         </p:txBody>
@@ -447,7 +448,7 @@
           <a:lstStyle/>
           <a:p>
             <a:r>
-              <a:t>BMF letter of 15 October 2026, section 2.5, para. 17: the invoice states the net amount per rate and the tax amount (§ 14 (4) sentence 1 no. 7 and 8 UStG); the net amount is the consideration minus the VAT (§ 10 (1) UStG); the tax amount is calculated to the cent and rounded commercially (UStAE 14.5 (20)). CJEU Ahold (C-484/06): Member States decide on rounding, within neutrality and proportionality; VAT is exactly proportional to the price (para. 38); where rounding is necessary, as closely as possible to the VAT of the rate (para. 39). VAT Directive: Art. 226(8) taxable amount per rate and unit price exclusive of VAT; Art. 206 net VAT paid with the return. ViDA: new Art. 232 (no acceptance needed), new Art. 263(3) (DRR).</a:t>
+              <a:t>BMF letter of 15 October 2026, section 2.5, para. 17: the invoice states the net amount per rate and the tax amount (§ 14 (4) sentence 1 no. 7 and 8 UStG); the net amount is the consideration minus the VAT (§ 10 (1) UStG); the tax amount is calculated to the cent and rounded commercially (UStAE 14.5 (20)). CJEU Ahold (C-484/06): Member States decide on rounding, within neutrality and proportionality; VAT is exactly proportional to the price (para. 38); where rounding is necessary, as closely as possible to the VAT of the rate (para. 39). VAT Directive: Art. 226(8) taxable amount per rate and unit price exclusive of VAT; Art. 206: the seller pays the VAT with the VAT return; Art. 168: the buyer deducts it as input VAT. ViDA: new Art. 232 (no acceptance needed), new Art. 263(3) (DRR).</a:t>
             </a:r>
           </a:p>
         </p:txBody>
@@ -631,7 +632,7 @@
           <a:lstStyle/>
           <a:p>
             <a:r>
-              <a:t>Decision 1 (#164): add the gross model to the core — the 'plus VAT' business terms (BT-146V, BT-131V, BT-116V and the others), VAT first (BT-117 = BT-116V × rate ÷ (100 + rate), rounded once; BT-116 = BT-116V − BT-117), no net intermediate values in the gross model, BT-146 Item net price for information (Art. 226(8)). Decision 2 (#163): no maximum decimal places for prices, quantities and intermediate values; only the paid amounts in the Minor Unit, BT-114 shows the one rounding; exact validation, within today's tolerance a warning, outside an error. Next steps: TAXUD on VAT first and on making the unit price exclusive of VAT optional for gross-price invoices; test documents; an impact test as Cyrille Sautereau requests.</a:t>
+              <a:t>Decision 1 (#164): add the gross model to the core — the 'plus VAT' business terms (BT-146V, BT-131V, BT-116V and the others), VAT first (BT-117 = BT-116V × rate ÷ (100 + rate), rounded once; BT-116 = BT-116V − BT-117), no net intermediate values in the gross model, BT-146 Item net price for information (Art. 226(8)). Decision 2 (#163): no maximum decimal places for prices, quantities and intermediate values; only the paid amounts and the VAT amounts in the Minor Unit, rounded once (BT-117 once per VAT category), BT-114 shows the rounding of BT-115; exact validation, each rule keeps today's tolerance and is an error only outside it, a warning only where a rounding changes BT-117 or BT-112. Next steps: TAXUD on VAT first and on making the unit price exclusive of VAT optional for gross-price invoices; test documents; an impact test as Cyrille Sautereau requests. The open points of the previous slide — one line amount or two, a maximum or none, BT-116 exact or in cents, VAT first as a rule or as guidance — can be settled within these two decisions.</a:t>
             </a:r>
           </a:p>
         </p:txBody>
@@ -723,7 +724,7 @@
           <a:lstStyle/>
           <a:p>
             <a:r>
-              <a:t>Fuel shows that the amounts of the gross model stay in cents: the tenth of a cent is in the price (1.799 EUR per litre), not in the amount. 45.37 litres × 1.799 = 81.62063, charged and paid at the pump as 81.62. That is the line amount plus VAT (BT-131V). VAT first: 81.62 × 19 ÷ 119 = 13.0317 → 13.03 (BT-117); the net amount is the remainder, 68.59 (BT-116). BT-116V, BT-112 and BT-115 are 81.62. The informational BT-146 Item net price is 1.799 ÷ 1.19 = 1.51176470…; it is not used in any calculation. A validator can still use it to confirm the VAT, but only with enough decimal places: in the book example of #164, 23.3178 × 1,000 gives 1,632.25 VAT, while 23.317757 × 1,000 gives the correct 1,632.24. How many decimal places are enough depends on the quantity, so the standard must not fix a maximum.</a:t>
+              <a:t>Fuel shows that the amounts of the gross model stay in cents: the tenth of a cent is in the price (1.799 EUR per litre), not in the amount. 45.37 litres × 1.799 = 81.62063, charged and paid at the pump as 81.62. That is the Invoice line net amount plus VAT (BT-131V). VAT first: 81.62 × 19 ÷ 119 = 13.0317 → 13.03 (BT-117); the net amount is the remainder, 68.59 (BT-116). BT-116V, BT-112 and BT-115 are 81.62. The informational BT-146 Item net price is 1.799 ÷ 1.19 = 1.51176470…; it is not used in any calculation. A validator can still use it to confirm the VAT, but only with enough decimal places: in the book example of #164, 23.3178 × 1,000 gives 1,632.25 VAT, while 23.317757 × 1,000 gives the correct 1,632.24. How many decimal places are enough depends on the quantity, so the standard must not fix a maximum.</a:t>
             </a:r>
           </a:p>
         </p:txBody>
@@ -769,7 +770,7 @@
           <a:lstStyle/>
           <a:p>
             <a:r>
-              <a:t>Impact on existing implementations. Issuers with net prices and 2 decimal places: nothing changes. Receivers with 2 decimal places: they round a received value once to their own precision when importing it — only for invoices that use more decimals, which are invalid today. Gross-price invoices: the new 'plus VAT' terms of #164 are a new core feature, like any amendment; a correct gross-price invoice was not possible before (BMF letter, para. 18; workaround until 31 December 2027, para. 19). Validators: exact decimal arithmetic at decimal128, test documents exist in Svanton. Syntaxes: no change, amounts are xsd:decimal. Every invoice that is valid today stays valid, at most with a warning (#163). For the impact study Cyrille Sautereau asks for, the precise question is whether a system rounds a precise value on import or rejects it.</a:t>
+              <a:t>Impact on existing implementations. Issuers with net prices and 2 decimal places: nothing changes. Receivers with 2 decimal places: they round a received value once to their own precision when importing it — only for invoices that use more decimals, which are not conformant today. Gross-price invoices: the new 'plus VAT' terms of #164 are a new core feature, like any amendment; a correct gross-price invoice was not possible before (BMF letter, para. 18; workaround until 31 December 2027, para. 19). Validators: exact decimal arithmetic at decimal128, test documents exist in Svanton. Syntaxes: no change, amounts are xsd:decimal. Every invoice that is conformant today stays conformant, at most with a warning (#163): each rule keeps today's tolerance, and a warning appears only where a rounding changes the VAT or the total. For the impact study Cyrille Sautereau asks for, the precise question is whether a system rounds a precise value on import or rejects it.</a:t>
             </a:r>
           </a:p>
         </p:txBody>
@@ -828,6 +829,67 @@
 </p:notes>
 </file>
 
+<file path=ppt/notesSlides/notesSlide21.xml><?xml version="1.0" encoding="utf-8"?>
+<p:notes xmlns:a="http://schemas.openxmlformats.org/drawingml/2006/main" xmlns:p="http://schemas.openxmlformats.org/presentationml/2006/main" xmlns:r="http://schemas.openxmlformats.org/officeDocument/2006/relationships">
+  <p:cSld>
+    <p:spTree>
+      <p:nvGrpSpPr>
+        <p:cNvPr id="1" name=""/>
+        <p:cNvGrpSpPr/>
+        <p:nvPr/>
+      </p:nvGrpSpPr>
+      <p:grpSpPr>
+        <a:xfrm>
+          <a:off x="0" y="0"/>
+          <a:ext cx="0" cy="0"/>
+          <a:chOff x="0" y="0"/>
+          <a:chExt cx="0" cy="0"/>
+        </a:xfrm>
+      </p:grpSpPr>
+      <p:sp>
+        <p:nvSpPr>
+          <p:cNvPr id="3" name="Notes Placeholder 2"/>
+          <p:cNvSpPr>
+            <a:spLocks noGrp="1"/>
+          </p:cNvSpPr>
+          <p:nvPr>
+            <p:ph type="body" idx="1"/>
+          </p:nvPr>
+        </p:nvSpPr>
+        <p:spPr/>
+        <p:txBody>
+          <a:bodyPr/>
+          <a:lstStyle/>
+          <a:p>
+            <a:r>
+              <a:t>Status 20 October 2026, after the comments of Paul Simons and Cyrille Sautereau of 16 to 19 October in #163 and #164. Paul Simons: 'We need to find a solution. At least something we agree upon.'</a:t>
+            </a:r>
+          </a:p>
+          <a:p>
+            <a:r>
+              <a:t>Where the proposals meet: the VAT amounts in the Minor Unit, rounded once per VAT category, because national VAT law requires the tax amount to the cent (Paul Simons, 16 Oct; Update 4 of #163). The 'plus VAT' terms such as BT-146V Item net price plus VAT and BT-131V Invoice line net amount plus VAT, and an indicator for prices including VAT, in the core (Cyrille Sautereau, 16 Oct; #164). Precise line values next to today's rounded ones and more decimals for prices than today: Cyrille Sautereau proposes BT-131NR, BT-92NR and BT-99NR with 8 decimals and the Item net price with 8 decimals, Paul Simons a shadow BT-131 with 8 decimals and a rounding amount per VAT breakdown. Today's invoices stay conformant, with a tolerance on sums: 0.005 × number of summed amounts (Cyrille Sautereau) or 0.005 × (1 + number of summed amounts) (#163).</a:t>
+            </a:r>
+          </a:p>
+          <a:p>
+            <a:r>
+              <a:t>Still open, each with the reason of #163: one line amount or two — one exact BT-131 Invoice line net amount carries both values, because the rounded value follows from it. A maximum of 8 decimals or none — any maximum fails at some quantity (8 decimals and 10,000,000 units: up to €0.05), and decimal128 counts its 34 significant digits before and after the decimal point together. BT-116 exact or in cents — rounding it per VAT category adds up again; a Member State can restrict it in its CIUS (Table 29). VAT first as a rule in the core or as guidance with national CIUS rules — #164 keeps today's tolerance of BR-S-9, so that rounding the base first stays conformant too.</a:t>
+            </a:r>
+          </a:p>
+          <a:p>
+            <a:r>
+              <a:t>In the end: accurate data that the seller, the buyer and the tax authority can trust. Conformant is not compliant: in the example of Paul Simons (#163, 19 Oct), the same supply gives €1.20 or €1.21; the EN tolerates the difference, while German law asks for the consideration and the tax amount (§ 14 (4) no. 7 and 8 UStG) without a tolerance. Nobody is forced to calculate more accurately than needed. Receivers round on import instead of rejecting, because from 1 July 2030 an invoice that complies with the EN needs no acceptance (new Art. 232, ViDA). Each software states its precision, and the market chooses.</a:t>
+            </a:r>
+          </a:p>
+        </p:txBody>
+      </p:sp>
+    </p:spTree>
+  </p:cSld>
+  <p:clrMapOvr>
+    <a:masterClrMapping/>
+  </p:clrMapOvr>
+</p:notes>
+</file>
+
 <file path=ppt/notesSlides/notesSlide24.xml><?xml version="1.0" encoding="utf-8"?>
 <p:notes xmlns:a="http://schemas.openxmlformats.org/drawingml/2006/main" xmlns:r="http://schemas.openxmlformats.org/officeDocument/2006/relationships" xmlns:p="http://schemas.openxmlformats.org/presentationml/2006/main">
   <p:cSld>
@@ -873,50 +935,37 @@
           <a:lstStyle/>
           <a:p>
             <a:r>
-              <a:rPr lang="en-GB" dirty="0"/>
-              <a:t>github.com/ConnectingEurope/CEN-TC434-WG1/issues/163 — 'Round only once: no rounding of intermediate values, only of the amounts that are paid are being rounded' (Update 3 of 14 Oct 2026).</a:t>
-            </a:r>
-          </a:p>
-          <a:p>
-            <a:r>
-              <a:rPr lang="en-GB" dirty="0"/>
+              <a:t>github.com/ConnectingEurope/CEN-TC434-WG1/issues/163 — 'Round only once: no rounding of intermediate values, only of the amounts that are paid are being rounded' (Update 4 of 16 Oct 2026).</a:t>
+            </a:r>
+          </a:p>
+          <a:p>
+            <a:r>
               <a:t>EN 16931-1:2026 already says the right thing in 6.5.14: the final result is rounded, not intermediate results. But that only applies per rule; Table 28 and the first indent of 6.5.14 force every result back to cents before it enters the next rule. That is why tolerances of up to EUR 1 are needed (BR-S-9, BR-IG-9, BR-IP-9).</a:t>
             </a:r>
           </a:p>
           <a:p>
             <a:r>
-              <a:rPr lang="en-GB" dirty="0"/>
-              <a:t>Update 3: only what is paid gets rounded — BT-115 Amount due for payment and the amounts that change it: BT-113 Paid amount, BT-172 Discount amount (early payment), BT-179 Charge amount collected on behalf of a third party, BT-183 Penalty amount (late payment). They are stated in the currency's Minor Unit (ISO 4217, column 'minor unit'; EUR: cent) — the bank does not transfer smaller amounts. BT-114 Rounding amount carries the one rounding. Everything else, VAT included, is stated as precisely as the issuer calculates.</a:t>
-            </a:r>
-          </a:p>
-          <a:p>
-            <a:r>
-              <a:rPr lang="en-GB" dirty="0"/>
-              <a:t>VAT is not transferred per invoice but with the VAT return (Art. 206 VAT Directive). How the VAT of an invoice is rounded is national law: if it requires cents — in Germany UStAE 14.5 (20) 'accurate to the cent' —, a national CIUS restricts BT-110 and BT-117 to the Minor Unit (EN 16931-1:2026, Table 29: 'Restrict allowed fraction digits'). The core validation reports this as a warning.</a:t>
-            </a:r>
-          </a:p>
-          <a:p>
-            <a:r>
-              <a:rPr lang="en-GB" dirty="0"/>
-              <a:t>Validation: exact from the stated values, with 34 digits for non-terminating divisions (IEEE 754 decimal128). Equal: valid. Within today's tolerance: valid with a warning — whether the deviation is accepted is decided by the tax administration; a warning does not protect against penalties. Outside: error. For sums 0.005 × (1 + number of addends) applies, as proposed in #164. The tolerances remain, no transition period is needed: every invoice valid today stays valid, at most with a warning.</a:t>
-            </a:r>
-          </a:p>
-          <a:p>
-            <a:r>
-              <a:rPr lang="en-GB" dirty="0"/>
-              <a:t>Recipients validate with this precision, book BT-115 Amount due for payment and may round all other values internally; the original invoice remains stored (Art. 233 and 244 VAT Directive). From 1 July 2030 an EN 16931 compliant e-invoice no longer needs the recipient's consent (new Art. 232, ViDA).</a:t>
-            </a:r>
-          </a:p>
-          <a:p>
-            <a:r>
-              <a:rPr lang="en-GB" dirty="0"/>
-              <a:t>Example receipt → invoice (#148): 1,000 × €9.99 incl. 19% VAT = €9,990.00 with €1,595.04 VAT. Today (BT-146 with 4 digits: 8.3950) the invoice gives €9,990.05 — 5 cents too much, VAT 1 cent too high. With #163 and 10 digits (8.3949579832): amount due €9,990.00, BT-114 = −0.000000008. With VAT in cents where the law requires it: €1,595.04 (warning), amount due €9,990.00.</a:t>
-            </a:r>
-          </a:p>
-          <a:p>
-            <a:r>
-              <a:rPr lang="en-GB" dirty="0"/>
-              <a:t>Discussion: the split into warning and error takes up the third option of Cyrille Sautereau (FR). Open are DRR reports with cent lines (FR: the PPF accepts up to 6 digits) and backward compatibility (Paul Simons). In 2020 WG1 already decided to lift the limitation of BT-131 (issue #7).</a:t>
+              <a:t>Update 4: only what is paid gets rounded, once. BT-115 Amount due for payment and the amounts that change it — BT-113 Paid amount, BT-172 Discount amount, BT-179 Charge amount collected on behalf of a third party, BT-183 Penalty amount — are in the currency's Minor Unit (ISO 4217; EUR: cent), because the bank transfers no smaller amounts. BT-114 Rounding amount carries the rounding of BT-115. The VAT is paid, too: the seller pays it with the VAT return (Art. 206 VAT Directive), the buyer deducts it (Art. 168). So BT-117 VAT category tax amount is rounded once per VAT category from the exact BT-116, because national VAT law requires the tax amount to the cent (UStAE 14.5 (20)); BT-110 Invoice total VAT amount is their sum, BT-111 is in the Minor Unit of the VAT accounting currency. BT-116 VAT category taxable amount stays exact, because rounding it per category adds up again: three categories that each lose 0.4 cents make the invoice one cent off. A Member State that requires it in cents can restrict it in its CIUS (Table 29).</a:t>
+            </a:r>
+          </a:p>
+          <a:p>
+            <a:r>
+              <a:t>Validation: exact from the stated values, with 34 significant digits for non-terminating divisions (IEEE 754 decimal128). Each rule accepts today's tolerance; outside it, the invoice is in error. For sums 0.005 × (1 + number of summed amounts), because each rounded amount is off by at most half a cent. A warning appears only where a rounding changes BT-117 or BT-112 Invoice total amount with VAT, compared with the exact calculation from the stated prices, quantities and rates — never an error, because a rounding that national law asks for should not warn by itself (Paul Simons). Whether a warned deviation is accepted is up to the tax authority; a warning does not protect against a penalty. No transition period: every invoice that is conformant today stays conformant, at most with a warning.</a:t>
+            </a:r>
+          </a:p>
+          <a:p>
+            <a:r>
+              <a:t>Recipients validate with this precision, book BT-115 and the VAT amounts and may round all other values internally; the original invoice remains stored (Art. 233 and 244 VAT Directive). From 1 July 2030 an EN 16931 compliant e-invoice no longer needs the recipient's acceptance (new Art. 232, ViDA).</a:t>
+            </a:r>
+          </a:p>
+          <a:p>
+            <a:r>
+              <a:t>Example receipt → invoice (#148): 1,000 × €9.99 incl. 19% VAT = €9,990.00 with €1,595.04 VAT. Today (BT-146 Item net price with 4 decimals: 8.3950) the invoice gives €9,990.05 — 5 cents too much, VAT 1 cent too high. With #163 and 10 decimals (8.3949579832): BT-116 8,394.9579832, BT-117 €1,595.04 (rounded once), BT-112 9,989.9979832, BT-114 0.0020168, BT-115 €9,990.00. Six decimals would also do here (BT-114 = 0.002); the precision needed depends on the quantity.</a:t>
+            </a:r>
+          </a:p>
+          <a:p>
+            <a:r>
+              <a:t>In 2020 WG1 already decided to lift the limitation of BT-131 (issue #7).</a:t>
             </a:r>
           </a:p>
         </p:txBody>
@@ -1002,55 +1051,46 @@
           <a:lstStyle/>
           <a:p>
             <a:r>
-              <a:rPr lang="en-GB" dirty="0"/>
               <a:t>Three slide pairs with identical layout — when paging through you only see the differences.</a:t>
             </a:r>
           </a:p>
           <a:p>
             <a:r>
-              <a:rPr lang="en-GB" dirty="0"/>
               <a:t>Rainbow: the seven calculated BTs run through the rainbow from top to bottom — BT-146 red, BT-131 orange, BT-106 yellow, BT-116 green, BT-117 blue, BT-110 violet, BT-115 magenta. Where a later line reuses one of them, it appears there in bold in the same colour (BT-146 in BT-131, BT-131 in BT-106 and BT-116, BT-116 in BT-117, BT-117 in BT-110, BT-110 in BT-115). Input values stay dark blue.</a:t>
             </a:r>
           </a:p>
           <a:p>
             <a:r>
-              <a:rPr lang="en-GB" dirty="0"/>
               <a:t>Frames: blue = input and intermediate values, violet = final results. The formulas show only the BT identifiers; the card titles and the panel on the right give the names from EN 16931-1. The panel lists every BT of the chain with its allowed decimal places, the calculated ones in their rainbow colour. All input values — including document level allowances and charges and the VAT rate — are in the upper box, below are the final results BT-116, BT-117, BT-110 and BT-115 Amount due for payment.</a:t>
             </a:r>
           </a:p>
           <a:p>
             <a:r>
-              <a:rPr lang="en-GB" dirty="0"/>
               <a:t>The ± values on the left apply to 100 lines of 100 units, 19% VAT, all roundings in the same direction. How far this can grow is shown on the slides 'How large does the deviation get?' (worst case with number of lines and quantity).</a:t>
             </a:r>
           </a:p>
           <a:p>
             <a:r>
-              <a:rPr lang="en-GB" dirty="0"/>
               <a:t>Colours of the decimal places: red = rounding forced by the standard on a value that is not paid (2017/2026: BT-131, BT-106, BT-116, BT-117, BT-110; 2026 also BT-146); green = paid amount, rounded once: BT-115 Amount due for payment — in 2017 fixed to 2 decimal places (Table 26), since 2026 to the currency's Minor Unit (ISO 4217; EUR: cent, JPY: whole yen, KWD: 3 decimal places); orange = input value that has to be rounded because of a limitation; 'free' = no limitation (#163). The VAT rate is a statutory constant and is not rounded.</a:t>
             </a:r>
           </a:p>
           <a:p>
             <a:r>
-              <a:rPr lang="en-GB" dirty="0"/>
-              <a:t>Why BT-116, BT-117 and BT-110 are no longer final values: according to Update 3 of #163 (14 Oct 2026) only what is paid gets rounded. VAT is paid with the VAT return, not per invoice (Art. 206 VAT Directive); the German advance VAT return even takes the taxable amount in whole euros only (BMF instructions 2026). If national law requires the VAT per invoice in cents (UStAE 14.5 (20)), a national CIUS restricts BT-117 and BT-110 to the Minor Unit (Table 29) — the core validation reports this as a warning.</a:t>
-            </a:r>
-          </a:p>
-          <a:p>
-            <a:r>
-              <a:rPr lang="en-GB" dirty="0"/>
+              <a:t>What #163 changes (Update 4, 16 Oct 2026): only what is paid gets rounded, once — BT-115 Amount due for payment and the VAT, which the seller pays with the VAT return (Art. 206 VAT Directive) and the buyer deducts (Art. 168). BT-117 VAT category tax amount is rounded once per VAT category from the exact BT-116 VAT category taxable amount, because national VAT law requires the tax amount to the cent (UStAE 14.5 (20)); BT-110 Invoice total VAT amount is their sum. BT-116 stays exact, because rounding it per category adds up again; a Member State that requires it in cents can restrict it in its CIUS (Table 29).</a:t>
+            </a:r>
+          </a:p>
+          <a:p>
+            <a:r>
               <a:t>BT-115 Amount due for payment = BT-112 Invoice total amount with VAT (BT-109 Invoice total amount without VAT + BT-110 Invoice total VAT amount) − BT-113 Paid amount + Σ BT-179 Charge amount collected on behalf of a third party + BT-114 Rounding amount (BR-CO-16). In 2017 and 2026 the errors of all intermediate roundings end up in BT-115 (± €0.60 and ± €1.19 respectively for 100 lines of 100 units); with #163 it is rounded once, and BT-114 shows this rounding.</a:t>
             </a:r>
           </a:p>
           <a:p>
             <a:r>
-              <a:rPr lang="en-GB" dirty="0"/>
               <a:t>2017 (Table 26): only amounts are limited — fixed to 2 decimal places, regardless of the currency; prices, quantities, base quantities and rates are unlimited. One intermediate rounding: BT-131 deviates by up to €0.005 per line, over 100 lines by up to €0.50; the VAT on it by up to €0.10 (9.5 cents, rounded).</a:t>
             </a:r>
           </a:p>
           <a:p>
             <a:r>
-              <a:rPr lang="en-GB" dirty="0"/>
               <a:t>Already in 2017 the table contradicts the text of the standard: 'Rounding shall be done on the final calculation results not on any intermediate results'.</a:t>
             </a:r>
           </a:p>
@@ -1137,56 +1177,47 @@
           <a:lstStyle/>
           <a:p>
             <a:r>
-              <a:rPr lang="en-GB" dirty="0"/>
               <a:t>Rainbow: the seven calculated BTs run through the rainbow from top to bottom — BT-146 red, BT-131 orange, BT-106 yellow, BT-116 green, BT-117 blue, BT-110 violet, BT-115 magenta. Where a later line reuses one of them, it appears there in bold in the same colour (BT-146 in BT-131, BT-131 in BT-106 and BT-116, BT-116 in BT-117, BT-117 in BT-110, BT-110 in BT-115). Input values stay dark blue.</a:t>
             </a:r>
           </a:p>
           <a:p>
             <a:r>
-              <a:rPr lang="en-GB" dirty="0"/>
               <a:t>Frames: blue = input and intermediate values, violet = final results. The formulas show only the BT identifiers; the card titles and the panel on the right give the names from EN 16931-1. The panel lists every BT of the chain with its allowed decimal places, the calculated ones in their rainbow colour. All input values — including document level allowances and charges and the VAT rate — are in the upper box, below are the final results BT-116, BT-117, BT-110 and BT-115 Amount due for payment.</a:t>
             </a:r>
           </a:p>
           <a:p>
             <a:r>
-              <a:rPr lang="en-GB" dirty="0"/>
               <a:t>The ± values on the left apply to 100 lines of 100 units, 19% VAT, all roundings in the same direction. How far this can grow is shown on the slides 'How large does the deviation get?' (worst case with number of lines and quantity).</a:t>
             </a:r>
           </a:p>
           <a:p>
             <a:r>
-              <a:rPr lang="en-GB" dirty="0"/>
               <a:t>Colours of the decimal places: red = rounding forced by the standard on a value that is not paid (2017/2026: BT-131, BT-106, BT-116, BT-117, BT-110; 2026 also BT-146); green = paid amount, rounded once: BT-115 Amount due for payment, to the currency's Minor Unit (ISO 4217; EUR: cent, JPY: whole yen, KWD: 3 decimal places); orange = input value that has to be rounded because of a limitation; 'free' = no limitation (#163). The VAT rate is a statutory constant and is not rounded.</a:t>
             </a:r>
           </a:p>
           <a:p>
             <a:r>
-              <a:rPr lang="en-GB" dirty="0"/>
-              <a:t>Why BT-116, BT-117 and BT-110 are no longer final values: according to Update 3 of #163 (14 Oct 2026) only what is paid gets rounded. VAT is paid with the VAT return, not per invoice (Art. 206 VAT Directive); the German advance VAT return even takes the taxable amount in whole euros only (BMF instructions 2026). If national law requires the VAT per invoice in cents (UStAE 14.5 (20)), a national CIUS restricts BT-117 and BT-110 to the Minor Unit (Table 29) — the core validation reports this as a warning.</a:t>
-            </a:r>
-          </a:p>
-          <a:p>
-            <a:r>
-              <a:rPr lang="en-GB" dirty="0"/>
+              <a:t>What #163 changes (Update 4, 16 Oct 2026): only what is paid gets rounded, once — BT-115 Amount due for payment and the VAT, which the seller pays with the VAT return (Art. 206 VAT Directive) and the buyer deducts (Art. 168). BT-117 VAT category tax amount is rounded once per VAT category from the exact BT-116 VAT category taxable amount, because national VAT law requires the tax amount to the cent (UStAE 14.5 (20)); BT-110 Invoice total VAT amount is their sum. BT-116 stays exact, because rounding it per category adds up again; a Member State that requires it in cents can restrict it in its CIUS (Table 29).</a:t>
+            </a:r>
+          </a:p>
+          <a:p>
+            <a:r>
               <a:t>BT-115 Amount due for payment = BT-112 Invoice total amount with VAT (BT-109 Invoice total amount without VAT + BT-110 Invoice total VAT amount) − BT-113 Paid amount + Σ BT-179 Charge amount collected on behalf of a third party + BT-114 Rounding amount (BR-CO-16). In 2017 and 2026 the errors of all intermediate roundings end up in BT-115 (± €0.60 and ± €1.19 respectively for 100 lines of 100 units); with #163 it is rounded once, and BT-114 shows this rounding.</a:t>
             </a:r>
           </a:p>
           <a:p>
             <a:r>
-              <a:rPr lang="en-GB" dirty="0"/>
               <a:t>2026 (Table 28): BT-146 to BT-148 to 'minor unit + 2' (EUR: 4), BT-129 to 4, BT-149 to 2, rates to 2, all amounts to the minor unit (EUR: 2). Two intermediate roundings: BT-146 (up to €0.00005 per unit) and BT-131.</a:t>
             </a:r>
           </a:p>
           <a:p>
             <a:r>
-              <a:rPr lang="en-GB" dirty="0"/>
               <a:t>Per line: 100 × €0.00005 from the price + €0.005 from the line rounding = €0.01. Over 100 lines: €1.00 net; VAT €1.00 × 19% = €0.19 (the offset of exactly 19 cents survives the rounding); total €1.19.</a:t>
             </a:r>
           </a:p>
           <a:p>
             <a:r>
-              <a:rPr lang="en-GB" dirty="0"/>
-              <a:t>The tolerances of the 2026 rules absorb such differences (up to EUR 1 for BR-S-9) — but they also hide them. With #163 they separate warning from error: the deviation becomes visible. A concrete example with figures (receipt 1,000 × €9.99): see the notes on #163.</a:t>
+              <a:t>The tolerances of the 2026 rules absorb such differences (up to EUR 1 for BR-S-9) — but they also hide them. With #163 each rule keeps them, and a warning shows where a rounding changes the VAT or the total: the deviation becomes visible. A concrete example with figures (receipt 1,000 × €9.99): see the notes on #163.</a:t>
             </a:r>
           </a:p>
         </p:txBody>
@@ -1272,50 +1303,42 @@
           <a:lstStyle/>
           <a:p>
             <a:r>
-              <a:rPr lang="en-GB" dirty="0"/>
               <a:t>Rainbow: the seven calculated BTs run through the rainbow from top to bottom — BT-146 red, BT-131 orange, BT-106 yellow, BT-116 green, BT-117 blue, BT-110 violet, BT-115 magenta. Where a later line reuses one of them, it appears there in bold in the same colour (BT-146 in BT-131, BT-131 in BT-106 and BT-116, BT-116 in BT-117, BT-117 in BT-110, BT-110 in BT-115). Input values stay dark blue.</a:t>
             </a:r>
           </a:p>
           <a:p>
             <a:r>
-              <a:rPr lang="en-GB" dirty="0"/>
               <a:t>Frames: blue = input and intermediate values, violet = final results. The formulas show only the BT identifiers; the card titles and the panel on the right give the names from EN 16931-1. The panel lists every BT of the chain with its allowed decimal places, the calculated ones in their rainbow colour. All input values — including document level allowances and charges and the VAT rate — are in the upper box, below are the final results BT-116, BT-117, BT-110 and BT-115 Amount due for payment.</a:t>
             </a:r>
           </a:p>
           <a:p>
             <a:r>
-              <a:rPr lang="en-GB" dirty="0"/>
               <a:t>The ± values on the left apply to 100 lines of 100 units, 19% VAT, all roundings in the same direction. How far this can grow is shown on the slides 'How large does the deviation get?' (worst case with number of lines and quantity).</a:t>
             </a:r>
           </a:p>
           <a:p>
             <a:r>
-              <a:rPr lang="en-GB" dirty="0"/>
-              <a:t>Colours of the decimal places: red = rounding forced by the standard on a value that is not paid (2017/2026: BT-131, BT-106, BT-116, BT-117, BT-110; 2026 also BT-146); green = paid amount, rounded once: BT-115 Amount due for payment, to the currency's Minor Unit (ISO 4217; EUR: cent, JPY: whole yen, KWD: 3 decimal places); orange = input value that has to be rounded because of a limitation; 'free' = no limitation (#163). The VAT rate is a statutory constant and is not rounded.</a:t>
-            </a:r>
-          </a:p>
-          <a:p>
-            <a:r>
-              <a:rPr lang="en-GB" dirty="0"/>
-              <a:t>Why BT-116, BT-117 and BT-110 are no longer final values: according to Update 3 of #163 (14 Oct 2026) only what is paid gets rounded. VAT is paid with the VAT return, not per invoice (Art. 206 VAT Directive); the German advance VAT return even takes the taxable amount in whole euros only (BMF instructions 2026). If national law requires the VAT per invoice in cents (UStAE 14.5 (20)), a national CIUS restricts BT-117 and BT-110 to the Minor Unit (Table 29) — the core validation reports this as a warning.</a:t>
-            </a:r>
-          </a:p>
-          <a:p>
-            <a:r>
-              <a:rPr lang="en-GB" dirty="0"/>
+              <a:t>Colours of the decimal places: red = rounding forced by the standard on a value that is not paid (2017/2026: BT-131, BT-106, BT-116, BT-117, BT-110; 2026 also BT-146); green = rounded once: BT-115 Amount due for payment and the VAT amounts BT-117 and BT-110, to the currency's Minor Unit (ISO 4217; EUR: cent, JPY: whole yen, KWD: 3 decimal places); orange = input value that has to be rounded because of a limitation; 'free' = no limitation (#163). The VAT rate is a statutory constant and is not rounded.</a:t>
+            </a:r>
+          </a:p>
+          <a:p>
+            <a:r>
+              <a:t>Update 4 of #163 (16 Oct 2026): only what is paid gets rounded, once. The VAT is paid, too: the seller pays it with the VAT return (Art. 206 VAT Directive) and the buyer deducts it (Art. 168). Because national VAT law requires the tax amount to the cent (UStAE 14.5 (20)), BT-117 VAT category tax amount is rounded once per VAT category from the exact BT-116, and BT-110 Invoice total VAT amount is the sum of BT-117. BT-116 VAT category taxable amount stays exact, because rounding it per category adds up again; a Member State that requires it in cents can restrict it in its CIUS (Table 29). The ± 0 of BT-117 means: it equals the VAT rounded once from the exact taxable amount, which is what the law asks for.</a:t>
+            </a:r>
+          </a:p>
+          <a:p>
+            <a:r>
               <a:t>BT-115 Amount due for payment = BT-112 Invoice total amount with VAT (BT-109 Invoice total amount without VAT + BT-110 Invoice total VAT amount) − BT-113 Paid amount + Σ BT-179 Charge amount collected on behalf of a third party + BT-114 Rounding amount (BR-CO-16). In 2017 and 2026 the errors of all intermediate roundings end up in BT-115 (± €0.60 and ± €1.19 respectively for 100 lines of 100 units); with #163 it is rounded once, and BT-114 shows this rounding.</a:t>
             </a:r>
           </a:p>
           <a:p>
             <a:r>
-              <a:rPr lang="en-GB" dirty="0"/>
               <a:t>Proposal #163: intermediate values are no longer rounded by force, input values (quantities, prices, percentages) no longer limited; the VAT rate stays at 2 decimal places as a statutory constant.</a:t>
             </a:r>
           </a:p>
           <a:p>
             <a:r>
-              <a:rPr lang="en-GB" dirty="0"/>
-              <a:t>Only BT-115 Amount due for payment is rounded (plus BT-113, BT-172, BT-179 and BT-183, which change it); BT-114 Rounding amount makes the one rounding visible. VAT stays as precise as calculated; cents only via a national CIUS, as a warning. So there is no deviation from intermediate rounding — for any number of lines.</a:t>
+              <a:t>Rounded once: BT-115 Amount due for payment (plus BT-113, BT-172, BT-179 and BT-183, which change it) and the VAT amounts BT-117 and BT-110; BT-114 Rounding amount makes the rounding of BT-115 visible. So there is no deviation from intermediate rounding — for any number of lines.</a:t>
             </a:r>
           </a:p>
         </p:txBody>
@@ -1524,62 +1547,52 @@
           <a:lstStyle/>
           <a:p>
             <a:r>
-              <a:rPr lang="en-GB" dirty="0"/>
               <a:t>How the deviation arises — step by step (EN 16931-1:2026):</a:t>
             </a:r>
           </a:p>
           <a:p>
             <a:r>
-              <a:rPr lang="en-GB" dirty="0"/>
               <a:t>1. BT-146 Item net price (factor 1): may only have Minor Unit + 2 decimal places (Table 28; EUR: 4). The exact price — e.g. €0.123449 from gross price minus discount or from a gross receipt — is 'squeezed' once into 4 digits: €0.1234. Error €0.000049, at most €0.00005 (half a unit of the 4th digit).</a:t>
             </a:r>
           </a:p>
           <a:p>
             <a:r>
-              <a:rPr lang="en-GB" dirty="0"/>
               <a:t>2. BT-131 Invoice line net amount = price × quantity: it is not rounded per unit — but the rounded price is in every unit. The quantity multiplies the one price error: 10,000 units × €0.000049 = €0.49 (WG1 issue #148: €1,234.00 instead of €1,234.49). At most Q × €0.00005.</a:t>
             </a:r>
           </a:p>
           <a:p>
             <a:r>
-              <a:rPr lang="en-GB" dirty="0"/>
               <a:t>3. In addition BT-131 is rounded to the Minor Unit (EUR: cent): once more up to €0.005. So per line up to Q × €0.00005 + €0.005 — that is what the first table row shows (100 units: €0.005 + €0.005 = €0.01; 10,000 units: €0.50 + €0.005 = €0.505; 1,000,000 units: €50.00 + €0.005 = €50.005).</a:t>
             </a:r>
           </a:p>
           <a:p>
             <a:r>
-              <a:rPr lang="en-GB" dirty="0"/>
               <a:t>4. BT-106 Sum of invoice line net amount and BT-116 VAT category taxable amount (factor 2) add up n lines. In the worst case in the same direction: n × (Q × €0.00005 + €0.005). The first table row shows the error per line as the sum of both parts (price × quantity + cent rounding); every further row is the number of lines × this value.</a:t>
             </a:r>
           </a:p>
           <a:p>
             <a:r>
-              <a:rPr lang="en-GB" dirty="0"/>
               <a:t>To recalculate: 100 lines of 10,000 units → per line 10,000 × €0.00005 + €0.005 = €0.505 → × 100 lines = €50.50 net. VAT: 19% × €50.50 = €9.595 → up to €9.60.</a:t>
             </a:r>
           </a:p>
           <a:p>
             <a:r>
-              <a:rPr lang="en-GB" dirty="0"/>
               <a:t>The corner of the table: 10,000 lines of 1,000,000 units → per line 1,000,000 × €0.00005 + €0.005 = €50.005 → × 10,000 lines = €500,050. Extreme, but it shows: open-ended. Large quantities occur e.g. in energy (kWh), small parts or data volume.</a:t>
             </a:r>
           </a:p>
           <a:p>
             <a:r>
-              <a:rPr lang="en-GB" dirty="0"/>
               <a:t>Why the price weighs more than the lines: the price error never cancels out within a line, it is multiplied in full by the quantity. Across many lines, however, roundings partly cancel out; the table shows the upper limit.</a:t>
             </a:r>
           </a:p>
           <a:p>
             <a:r>
-              <a:rPr lang="en-GB" dirty="0"/>
               <a:t>Likewise BT-129 Invoiced quantity is limited to 4 decimal places: for expensive items up to 0.00005 × price is missing per line (e.g. 0.00005 kg × €20,000/kg = €1.00).</a:t>
             </a:r>
           </a:p>
           <a:p>
             <a:r>
-              <a:rPr lang="en-GB" dirty="0"/>
-              <a:t>The tolerances of the 2026 rules (up to EUR 1, e.g. BR-S-9) only absorb small deviations — and hide the cause. With #163 the same tolerances separate warning from error: the deviation becomes visible instead of hidden.</a:t>
+              <a:t>The tolerances of the 2026 rules (up to EUR 1, e.g. BR-S-9) only absorb small deviations — and hide the cause. With #163 each rule keeps the same tolerances, and a warning shows where a rounding changes the VAT or the total: the deviation becomes visible instead of hidden.</a:t>
             </a:r>
           </a:p>
         </p:txBody>
@@ -1665,32 +1678,27 @@
           <a:lstStyle/>
           <a:p>
             <a:r>
-              <a:rPr lang="en-GB" dirty="0"/>
               <a:t>How the deviation stays at zero — step by step (proposal #163):</a:t>
             </a:r>
           </a:p>
           <a:p>
             <a:r>
-              <a:rPr lang="en-GB" dirty="0"/>
               <a:t>1. BT-146 Item net price and BT-129 Invoiced quantity stay exact, their decimal places are not limited. Factor 1 (price rounding × quantity) does not apply.</a:t>
             </a:r>
           </a:p>
           <a:p>
             <a:r>
-              <a:rPr lang="en-GB" dirty="0"/>
               <a:t>2. BT-131 Invoice line net amount and BT-106 Sum of invoice line net amount are not rounded but carried forward exactly. Factor 2 (number of lines) does not apply — no matter how many lines.</a:t>
             </a:r>
           </a:p>
           <a:p>
             <a:r>
-              <a:rPr lang="en-GB" dirty="0"/>
-              <a:t>3. Only what is paid gets rounded: BT-115 Amount due for payment, once from the exact total to the currency's Minor Unit (EUR: cent); BT-114 Rounding amount shows this one rounding. BT-117 VAT category tax amount and BT-116 VAT category taxable amount stay as precise as calculated. If national law requires the VAT in cents (UStAE 14.5 (20)), a national CIUS restricts it — validation reports this as a warning, not as an error.</a:t>
-            </a:r>
-          </a:p>
-          <a:p>
-            <a:r>
-              <a:rPr lang="en-GB" dirty="0"/>
-              <a:t>Result: ± 0 deviation from intermediate rounding, for any quantity and any number of lines. The prerequisite is exact decimal arithmetic — see the slides on exact invoice arithmetic.</a:t>
+              <a:t>3. Only what is paid gets rounded, once: BT-115 Amount due for payment, from the exact total to the currency's Minor Unit (EUR: cent), and BT-117 VAT category tax amount, once per VAT category from the exact BT-116 VAT category taxable amount, because national VAT law requires the tax amount to the cent (UStAE 14.5 (20)). BT-114 Rounding amount shows the rounding of BT-115. BT-116 stays as precise as calculated.</a:t>
+            </a:r>
+          </a:p>
+          <a:p>
+            <a:r>
+              <a:t>Result: ± 0 deviation from intermediate rounding, for any quantity and any number of lines; the VAT equals the VAT rounded once from the exact taxable amount. The prerequisite is exact decimal arithmetic — see the slides on exact invoice arithmetic.</a:t>
             </a:r>
           </a:p>
         </p:txBody>
@@ -1796,7 +1804,7 @@
           </a:p>
           <a:p>
             <a:r>
-              <a:t>Complements #163: in both models only the paid amounts are rounded, such as BT-115 Amount due for payment; the extracted BT-117 VAT category tax amount is stated as calculated, in cents only under national law (warning). In the example that is the only rounding: VAT first, €1,632.24299… becomes €1,632.24, the net amount is the remainder. In the gross model BT-146 is checked as a derived information price with half a unit of its last digit — without a warning, because it does not enter any calculation. In the discussion Paul Simons alternatively proposes category N with an exemption reason; Cyrille Sautereau supports gross prices in the model, with an indicator.</a:t>
+              <a:t>Complements #163: in both models only what is paid gets rounded, once: BT-115 Amount due for payment and the VAT; the extracted BT-117 VAT category tax amount is rounded once per VAT category to the cent. Today's tolerance of BR-S-9 stays, so that rounding the base first, as in France, stays conformant too. In the example that is the only rounding: VAT first, €1,632.24299… becomes €1,632.24, the net amount is the remainder. In the gross model BT-146 is checked as a derived information price with half a unit of its last digit — without a warning, because it does not enter any calculation. In the discussion Paul Simons alternatively proposes category N with an exemption reason; Cyrille Sautereau now proposes the 'plus VAT' terms and an indicator for prices including VAT in the core (#163, 16 Oct 2026); the presence of BT-146V on each line selects the model, an indicator may state it as well.</a:t>
             </a:r>
           </a:p>
           <a:p>
@@ -4215,7 +4223,7 @@
                 <a:ea typeface="Inter SemiBold Text SemiBold" pitchFamily="34" charset="-122"/>
                 <a:cs typeface="Inter SemiBold Text SemiBold" pitchFamily="34" charset="-120"/>
               </a:rPr>
-              <a:t>AMENDMENT · MY PROPOSAL 1/2</a:t>
+              <a:t>AMENDMENT · PROPOSAL 1/2</a:t>
             </a:r>
           </a:p>
         </p:txBody>
@@ -5349,7 +5357,7 @@
                 <a:ea typeface="Inter Text" pitchFamily="34" charset="-122"/>
                 <a:cs typeface="Inter Text" pitchFamily="34" charset="-120"/>
               </a:rPr>
-              <a:t>The model is selected via BT-146V on each line — no indicator needed. BT-146 remains mandatory (</a:t>
+              <a:t>BT-146V on each line selects the model; an indicator may confirm it. BT-146 remains mandatory (</a:t>
             </a:r>
             <a:r>
               <a:rPr lang="en-GB" sz="1100" dirty="0">
@@ -9514,7 +9522,7 @@
                           <a:ea typeface="Inter SemiBold Text SemiBold" pitchFamily="34" charset="-122"/>
                           <a:cs typeface="Inter SemiBold Text SemiBold" pitchFamily="34" charset="-120"/>
                         </a:rPr>
-                        <a:t>BT-131V Line amount plus VAT</a:t>
+                        <a:t>BT-131V Invoice line net amount plus VAT</a:t>
                       </a:r>
                     </a:p>
                   </a:txBody>
@@ -10915,7 +10923,7 @@
                 <a:ea typeface="Inter SemiBold Text SemiBold" pitchFamily="34" charset="-122"/>
                 <a:cs typeface="Inter SemiBold Text SemiBold" pitchFamily="34" charset="-120"/>
               </a:rPr>
-              <a:t>AMENDMENT · MY PROPOSAL 2/2</a:t>
+              <a:t>AMENDMENT · PROPOSAL 2/2</a:t>
             </a:r>
           </a:p>
         </p:txBody>
@@ -11009,7 +11017,7 @@
                 <a:ea typeface="Inter Text" pitchFamily="34" charset="-122"/>
                 <a:cs typeface="Inter Text" pitchFamily="34" charset="-120"/>
               </a:rPr>
-              <a:t>Only what is paid gets rounded — nothing else.</a:t>
+              <a:t>Only what is paid gets rounded, once: the amount due and the VAT.</a:t>
             </a:r>
           </a:p>
         </p:txBody>
@@ -11194,7 +11202,7 @@
                 <a:ea typeface="Inter SemiBold Text SemiBold" pitchFamily="34" charset="-122"/>
                 <a:cs typeface="Inter SemiBold Text SemiBold" pitchFamily="34" charset="-120"/>
               </a:rPr>
-              <a:t>Paid amounts — rounded once</a:t>
+              <a:t>Paid amounts and VAT — rounded once</a:t>
             </a:r>
           </a:p>
         </p:txBody>
@@ -11256,7 +11264,7 @@
                 <a:ea typeface="Inter Text" pitchFamily="34" charset="-122"/>
                 <a:cs typeface="Inter Text" pitchFamily="34" charset="-120"/>
               </a:rPr>
-              <a:t>BT-114 Rounding amount carries the one rounding</a:t>
+              <a:t>BT-117 VAT category tax amount: once per VAT category</a:t>
             </a:r>
           </a:p>
           <a:p>
@@ -11276,7 +11284,27 @@
                 <a:ea typeface="Inter Text" pitchFamily="34" charset="-122"/>
                 <a:cs typeface="Inter Text" pitchFamily="34" charset="-120"/>
               </a:rPr>
-              <a:t>BT-113, BT-172, BT-179, BT-183 likewise — they change the amount due</a:t>
+              <a:t>BT-114 Rounding amount carries the rounding of BT-115</a:t>
+            </a:r>
+          </a:p>
+          <a:p>
+            <a:pPr marL="164592" indent="-164592" algn="l">
+              <a:spcAft>
+                <a:spcPts val="200"/>
+              </a:spcAft>
+              <a:buSzPct val="100000"/>
+              <a:buChar char="•"/>
+            </a:pPr>
+            <a:r>
+              <a:rPr lang="en-GB" sz="1200" dirty="0">
+                <a:solidFill>
+                  <a:srgbClr val="5B6890"/>
+                </a:solidFill>
+                <a:latin typeface="Inter Text" pitchFamily="34" charset="0"/>
+                <a:ea typeface="Inter Text" pitchFamily="34" charset="-122"/>
+                <a:cs typeface="Inter Text" pitchFamily="34" charset="-120"/>
+              </a:rPr>
+              <a:t>Likewise BT-110, BT-111, BT-113, BT-172, BT-179, BT-183</a:t>
             </a:r>
           </a:p>
         </p:txBody>
@@ -11415,7 +11443,7 @@
                 <a:ea typeface="Inter SemiBold Text SemiBold" pitchFamily="34" charset="-122"/>
                 <a:cs typeface="Inter SemiBold Text SemiBold" pitchFamily="34" charset="-120"/>
               </a:rPr>
-              <a:t>Everything else, VAT included: as calculated</a:t>
+              <a:t>Everything else: as calculated</a:t>
             </a:r>
           </a:p>
         </p:txBody>
@@ -11457,7 +11485,7 @@
                 <a:ea typeface="Inter Text" pitchFamily="34" charset="-122"/>
                 <a:cs typeface="Inter Text" pitchFamily="34" charset="-120"/>
               </a:rPr>
-              <a:t>Prices, lines, totals, taxable amount and VAT</a:t>
+              <a:t>Prices, quantities, line amounts and sums: no maximum dp</a:t>
             </a:r>
           </a:p>
           <a:p>
@@ -11477,7 +11505,7 @@
                 <a:ea typeface="Inter Text" pitchFamily="34" charset="-122"/>
                 <a:cs typeface="Inter Text" pitchFamily="34" charset="-120"/>
               </a:rPr>
-              <a:t>Cent VAT only via a national CIUS (e.g. UStAE 14.5 (20))</a:t>
+              <a:t>BT-116 VAT category taxable amount: exact, cents via CIUS</a:t>
             </a:r>
           </a:p>
           <a:p>
@@ -11497,7 +11525,7 @@
                 <a:ea typeface="Inter Text" pitchFamily="34" charset="-122"/>
                 <a:cs typeface="Inter Text" pitchFamily="34" charset="-120"/>
               </a:rPr>
-              <a:t>Rounding to the Minor Unit today stays valid (warning)</a:t>
+              <a:t>Because the decimals needed grow with quantity and lines</a:t>
             </a:r>
           </a:p>
         </p:txBody>
@@ -11789,7 +11817,7 @@
                 <a:ea typeface="Inter Text" pitchFamily="34" charset="-122"/>
                 <a:cs typeface="Inter Text" pitchFamily="34" charset="-120"/>
               </a:rPr>
-              <a:t>Exact validation (decimal128): equal → valid, within tolerance → warning, otherwise error</a:t>
+              <a:t>Exact validation (decimal128); each rule keeps today's tolerance</a:t>
             </a:r>
           </a:p>
         </p:txBody>
@@ -11897,7 +11925,7 @@
                 <a:ea typeface="Inter Text" pitchFamily="34" charset="-122"/>
                 <a:cs typeface="Inter Text" pitchFamily="34" charset="-120"/>
               </a:rPr>
-              <a:t>Today's tolerances remain — they now separate warning from error</a:t>
+              <a:t>Error only outside it; a warning only where a rounding changes BT-117 or BT-112</a:t>
             </a:r>
           </a:p>
         </p:txBody>
@@ -12160,7 +12188,7 @@
                 <a:ea typeface="Inter SemiBold Text SemiBold" pitchFamily="34" charset="-122"/>
                 <a:cs typeface="Inter SemiBold Text SemiBold" pitchFamily="34" charset="-120"/>
               </a:rPr>
-              <a:t>Status 14 Oct 2026: Update 3 in WG1  ·  </a:t>
+              <a:t>Status 16 Oct 2026: Update 4 in WG1  ·  </a:t>
             </a:r>
             <a:r>
               <a:rPr lang="en-GB" sz="1100" dirty="0">
@@ -12171,7 +12199,7 @@
                 <a:ea typeface="Inter Text" pitchFamily="34" charset="-122"/>
                 <a:cs typeface="Inter Text" pitchFamily="34" charset="-120"/>
               </a:rPr>
-              <a:t>warning/error following </a:t>
+              <a:t>VAT in cents, as </a:t>
             </a:r>
             <a:r>
               <a:rPr lang="en-GB" sz="1100" dirty="0">
@@ -12181,7 +12209,7 @@
                 <a:latin typeface="Inter Text" pitchFamily="34" charset="0"/>
                 <a:ea typeface="Inter Text" pitchFamily="34" charset="-122"/>
                 <a:cs typeface="Inter Text" pitchFamily="34" charset="-120"/>
-                <a:hlinkClick r:id="rId7">
+                <a:hlinkClick r:id="rId8">
                   <a:extLst>
                     <a:ext uri="{A12FA001-AC4F-418D-AE19-62706E023703}">
                       <ahyp:hlinkClr xmlns:ahyp="http://schemas.microsoft.com/office/drawing/2018/hyperlinkcolor" val="tx"/>
@@ -12189,7 +12217,7 @@
                   </a:extLst>
                 </a:hlinkClick>
               </a:rPr>
-              <a:t>Cyrille Sautereau's 3rd option</a:t>
+              <a:t>Paul Simons</a:t>
             </a:r>
             <a:r>
               <a:rPr lang="en-GB" sz="1100" dirty="0">
@@ -12200,7 +12228,7 @@
                 <a:ea typeface="Inter Text" pitchFamily="34" charset="-122"/>
                 <a:cs typeface="Inter Text" pitchFamily="34" charset="-120"/>
               </a:rPr>
-              <a:t> · open: DRR with cent lines (FR), backward compatibility</a:t>
+              <a:t> asked; no warning for a rounding that does not change the result</a:t>
             </a:r>
           </a:p>
         </p:txBody>
@@ -12598,7 +12626,7 @@
                 <a:ea typeface="Inter Text" pitchFamily="34" charset="-122"/>
                 <a:cs typeface="Inter Text" pitchFamily="34" charset="-120"/>
               </a:rPr>
-              <a:t>— only BT-115 Amount due for payment is rounded; BT-114 Rounding amount shows it.</a:t>
+              <a:t>— only BT-115 Amount due for payment and BT-117 VAT category tax amount are rounded, once.</a:t>
             </a:r>
           </a:p>
         </p:txBody>
@@ -14500,11 +14528,11 @@
             </a:avLst>
           </a:prstGeom>
           <a:solidFill>
-            <a:srgbClr val="F4F6FB"/>
+            <a:srgbClr val="E8F6EE"/>
           </a:solidFill>
           <a:ln w="9525">
             <a:solidFill>
-              <a:srgbClr val="E2E7F2"/>
+              <a:srgbClr val="B7E1C7"/>
             </a:solidFill>
             <a:prstDash val="solid"/>
           </a:ln>
@@ -14519,13 +14547,13 @@
             <a:r>
               <a:rPr lang="en-GB" sz="1150" dirty="0">
                 <a:solidFill>
-                  <a:srgbClr val="5B6890"/>
+                  <a:srgbClr val="1E8A4C"/>
                 </a:solidFill>
                 <a:latin typeface="Inter SemiBold Text SemiBold" pitchFamily="34" charset="0"/>
                 <a:ea typeface="Inter SemiBold Text SemiBold" pitchFamily="34" charset="-122"/>
                 <a:cs typeface="Inter SemiBold Text SemiBold" pitchFamily="34" charset="-120"/>
               </a:rPr>
-              <a:t>free</a:t>
+              <a:t>Minor Unit</a:t>
             </a:r>
           </a:p>
           <a:p>
@@ -14535,13 +14563,13 @@
             <a:r>
               <a:rPr lang="en-GB" sz="800" dirty="0">
                 <a:solidFill>
-                  <a:srgbClr val="5B6890"/>
-                </a:solidFill>
-                <a:latin typeface="Inter Text" pitchFamily="34" charset="0"/>
-                <a:ea typeface="Inter Text" pitchFamily="34" charset="-122"/>
-                <a:cs typeface="Inter Text" pitchFamily="34" charset="-120"/>
-              </a:rPr>
-              <a:t>unrounded</a:t>
+                  <a:srgbClr val="1E8A4C"/>
+                </a:solidFill>
+                <a:latin typeface="Inter Text" pitchFamily="34" charset="0"/>
+                <a:ea typeface="Inter Text" pitchFamily="34" charset="-122"/>
+                <a:cs typeface="Inter Text" pitchFamily="34" charset="-120"/>
+              </a:rPr>
+              <a:t>rounded once</a:t>
             </a:r>
           </a:p>
         </p:txBody>
@@ -14617,7 +14645,7 @@
                 <a:ea typeface="Inter Text" pitchFamily="34" charset="-122"/>
                 <a:cs typeface="Inter Text" pitchFamily="34" charset="-120"/>
               </a:rPr>
-              <a:t>Minor Unit only via CIUS → warning</a:t>
+              <a:t>once per VAT category</a:t>
             </a:r>
           </a:p>
         </p:txBody>
@@ -14846,11 +14874,11 @@
             </a:avLst>
           </a:prstGeom>
           <a:solidFill>
-            <a:srgbClr val="F4F6FB"/>
+            <a:srgbClr val="E8F6EE"/>
           </a:solidFill>
           <a:ln w="9525">
             <a:solidFill>
-              <a:srgbClr val="E2E7F2"/>
+              <a:srgbClr val="B7E1C7"/>
             </a:solidFill>
             <a:prstDash val="solid"/>
           </a:ln>
@@ -14865,13 +14893,13 @@
             <a:r>
               <a:rPr lang="en-GB" sz="1150" dirty="0">
                 <a:solidFill>
-                  <a:srgbClr val="5B6890"/>
+                  <a:srgbClr val="1E8A4C"/>
                 </a:solidFill>
                 <a:latin typeface="Inter SemiBold Text SemiBold" pitchFamily="34" charset="0"/>
                 <a:ea typeface="Inter SemiBold Text SemiBold" pitchFamily="34" charset="-122"/>
                 <a:cs typeface="Inter SemiBold Text SemiBold" pitchFamily="34" charset="-120"/>
               </a:rPr>
-              <a:t>free</a:t>
+              <a:t>Minor Unit</a:t>
             </a:r>
           </a:p>
           <a:p>
@@ -14881,13 +14909,13 @@
             <a:r>
               <a:rPr lang="en-GB" sz="800" dirty="0">
                 <a:solidFill>
-                  <a:srgbClr val="5B6890"/>
-                </a:solidFill>
-                <a:latin typeface="Inter Text" pitchFamily="34" charset="0"/>
-                <a:ea typeface="Inter Text" pitchFamily="34" charset="-122"/>
-                <a:cs typeface="Inter Text" pitchFamily="34" charset="-120"/>
-              </a:rPr>
-              <a:t>unrounded</a:t>
+                  <a:srgbClr val="1E8A4C"/>
+                </a:solidFill>
+                <a:latin typeface="Inter Text" pitchFamily="34" charset="0"/>
+                <a:ea typeface="Inter Text" pitchFamily="34" charset="-122"/>
+                <a:cs typeface="Inter Text" pitchFamily="34" charset="-120"/>
+              </a:rPr>
+              <a:t>Σ of BT-117</a:t>
             </a:r>
           </a:p>
         </p:txBody>
@@ -15251,13 +15279,13 @@
             <a:r>
               <a:rPr lang="en-GB" sz="1000" dirty="0">
                 <a:solidFill>
-                  <a:srgbClr val="58D6BB"/>
+                  <a:srgbClr val="81C784"/>
                 </a:solidFill>
                 <a:latin typeface="Inter SemiBold Text SemiBold" pitchFamily="34" charset="0"/>
                 <a:ea typeface="Inter SemiBold Text SemiBold" pitchFamily="34" charset="-122"/>
                 <a:cs typeface="Inter SemiBold Text SemiBold" pitchFamily="34" charset="-120"/>
               </a:rPr>
-              <a:t>free</a:t>
+              <a:t>Minor Unit</a:t>
             </a:r>
           </a:p>
         </p:txBody>
@@ -15338,13 +15366,13 @@
             <a:r>
               <a:rPr lang="en-GB" sz="1000" dirty="0">
                 <a:solidFill>
-                  <a:srgbClr val="58D6BB"/>
+                  <a:srgbClr val="81C784"/>
                 </a:solidFill>
                 <a:latin typeface="Inter SemiBold Text SemiBold" pitchFamily="34" charset="0"/>
                 <a:ea typeface="Inter SemiBold Text SemiBold" pitchFamily="34" charset="-122"/>
                 <a:cs typeface="Inter SemiBold Text SemiBold" pitchFamily="34" charset="-120"/>
               </a:rPr>
-              <a:t>free</a:t>
+              <a:t>Minor Unit</a:t>
             </a:r>
           </a:p>
         </p:txBody>
@@ -15480,7 +15508,7 @@
                 <a:ea typeface="Inter Text" pitchFamily="34" charset="-122"/>
                 <a:cs typeface="Inter Text" pitchFamily="34" charset="-120"/>
               </a:rPr>
-              <a:t> = paid amount, rounded once (bank)   </a:t>
+              <a:t> = paid amount or VAT, rounded once   </a:t>
             </a:r>
             <a:r>
               <a:rPr lang="en-GB" sz="850" dirty="0">
@@ -19601,7 +19629,7 @@
                 <a:ea typeface="Inter Text" pitchFamily="34" charset="-122"/>
                 <a:cs typeface="Inter Text" pitchFamily="34" charset="-120"/>
               </a:rPr>
-              <a:t>Only BT-115 Amount due for payment is rounded once; BT-114 Rounding amount shows it.</a:t>
+              <a:t>Only BT-115 Amount due for payment and BT-117 VAT category tax amount are rounded, once.</a:t>
             </a:r>
           </a:p>
         </p:txBody>
@@ -21030,7 +21058,7 @@
                 <a:ea typeface="Inter Text" pitchFamily="34" charset="-122"/>
                 <a:cs typeface="Inter Text" pitchFamily="34" charset="-120"/>
               </a:rPr>
-              <a:t>Removing a maximum is not a minimum: every invoice that is valid today stays valid, at most with a warning </a:t>
+              <a:t>Removing a maximum is not a minimum: every invoice that is conformant today stays conformant, at most with a warning </a:t>
             </a:r>
             <a:r>
               <a:rPr lang="en-GB" sz="1100" dirty="0">
@@ -21428,7 +21456,7 @@
                 <a:ea typeface="Inter Text" pitchFamily="34" charset="-122"/>
                 <a:cs typeface="Inter Text" pitchFamily="34" charset="-120"/>
               </a:rPr>
-              <a:t>Invoices with 2 decimal places stay valid</a:t>
+              <a:t>Invoices with 2 decimal places stay conformant</a:t>
             </a:r>
           </a:p>
         </p:txBody>
@@ -21752,7 +21780,7 @@
                 <a:ea typeface="Inter Text" pitchFamily="34" charset="-122"/>
                 <a:cs typeface="Inter Text" pitchFamily="34" charset="-120"/>
               </a:rPr>
-              <a:t>Today's tolerances remain: a warning instead of silence</a:t>
+              <a:t>Today's tolerances remain; warning only if the result changes</a:t>
             </a:r>
           </a:p>
         </p:txBody>
@@ -23455,7 +23483,7 @@
                 <a:ea typeface="Inter Text" pitchFamily="34" charset="-122"/>
                 <a:cs typeface="Inter Text" pitchFamily="34" charset="-120"/>
               </a:rPr>
-              <a:t>Both keep every working implementation valid.</a:t>
+              <a:t>Both keep every working implementation conformant.</a:t>
             </a:r>
           </a:p>
         </p:txBody>
@@ -23493,7 +23521,7 @@
                 <a:ea typeface="Inter SemiBold Text SemiBold" pitchFamily="34" charset="-122"/>
                 <a:cs typeface="Inter SemiBold Text SemiBold" pitchFamily="34" charset="-120"/>
               </a:rPr>
-              <a:t>19</a:t>
+              <a:t>20</a:t>
             </a:fld>
             <a:endParaRPr lang="en-GB" sz="1000" spc="200" dirty="0">
               <a:solidFill>
@@ -23959,7 +23987,7 @@
                 <a:ea typeface="Inter Text" pitchFamily="34" charset="-122"/>
                 <a:cs typeface="Inter Text" pitchFamily="34" charset="-120"/>
               </a:rPr>
-              <a:t>Only paid amounts in the Minor Unit; BT-114 shows it</a:t>
+              <a:t>Only paid amounts and VAT rounded, once; BT-114 shows it</a:t>
             </a:r>
           </a:p>
           <a:p>
@@ -23979,7 +24007,7 @@
                 <a:ea typeface="Inter Text" pitchFamily="34" charset="-122"/>
                 <a:cs typeface="Inter Text" pitchFamily="34" charset="-120"/>
               </a:rPr>
-              <a:t>Exact validation: within tolerance warning, else error</a:t>
+              <a:t>Today's tolerances stay; warning only if the result changes</a:t>
             </a:r>
           </a:p>
         </p:txBody>
@@ -24828,7 +24856,7 @@
                 <a:ea typeface="Inter Text" pitchFamily="34" charset="-122"/>
                 <a:cs typeface="Inter Text" pitchFamily="34" charset="-120"/>
               </a:rPr>
-              <a:t>Three goals that WG1 shares — and that do not exclude each other.</a:t>
+              <a:t>In the end, we all want accurate data — and these goals do not exclude each other.</a:t>
             </a:r>
           </a:p>
         </p:txBody>
@@ -25305,7 +25333,7 @@
                 <a:ea typeface="Inter Text" pitchFamily="34" charset="-122"/>
                 <a:cs typeface="Inter Text" pitchFamily="34" charset="-120"/>
               </a:rPr>
-              <a:t>Invoices with 2 decimal places stay valid</a:t>
+              <a:t>Invoices with 2 decimal places stay conformant</a:t>
             </a:r>
           </a:p>
           <a:p>
@@ -26265,7 +26293,7 @@
                 <a:ea typeface="Inter SemiBold Text SemiBold" pitchFamily="34" charset="-122"/>
                 <a:cs typeface="Inter SemiBold Text SemiBold" pitchFamily="34" charset="-120"/>
               </a:rPr>
-              <a:t>20</a:t>
+              <a:t>21</a:t>
             </a:fld>
             <a:endParaRPr lang="en-GB" sz="1000" spc="200" dirty="0">
               <a:solidFill>
@@ -26926,6 +26954,1448 @@
                 <a:cs typeface="Inter Medium Text Medium" pitchFamily="34" charset="-120"/>
               </a:rPr>
               <a:t>Slides as PPTX</a:t>
+            </a:r>
+          </a:p>
+        </p:txBody>
+      </p:sp>
+    </p:spTree>
+  </p:cSld>
+  <p:clrMapOvr>
+    <a:masterClrMapping/>
+  </p:clrMapOvr>
+</p:sld>
+</file>
+
+<file path=ppt/slides/slide21.xml><?xml version="1.0" encoding="utf-8"?>
+<p:sld xmlns:a="http://schemas.openxmlformats.org/drawingml/2006/main" xmlns:p="http://schemas.openxmlformats.org/presentationml/2006/main" xmlns:r="http://schemas.openxmlformats.org/officeDocument/2006/relationships">
+  <p:cSld>
+    <p:spTree>
+      <p:nvGrpSpPr>
+        <p:cNvPr id="1" name=""/>
+        <p:cNvGrpSpPr/>
+        <p:nvPr/>
+      </p:nvGrpSpPr>
+      <p:grpSpPr/>
+      <p:sp>
+        <p:nvSpPr>
+          <p:cNvPr id="3" name="Header 3"/>
+          <p:cNvSpPr txBox="1"/>
+          <p:nvPr/>
+        </p:nvSpPr>
+        <p:spPr>
+          <a:xfrm>
+            <a:off x="822960" y="384048"/>
+            <a:ext cx="7315200" cy="274320"/>
+          </a:xfrm>
+          <a:prstGeom prst="rect">
+            <a:avLst/>
+          </a:prstGeom>
+          <a:noFill/>
+          <a:ln/>
+        </p:spPr>
+        <p:txBody>
+          <a:bodyPr wrap="square" lIns="0" tIns="0" rIns="0" bIns="0" rtlCol="0" anchor="ctr"/>
+          <a:lstStyle/>
+          <a:p>
+            <a:pPr marL="0" indent="0" algn="l">
+              <a:buNone/>
+            </a:pPr>
+            <a:r>
+              <a:rPr lang="en-GB" sz="950" spc="100" dirty="0">
+                <a:solidFill>
+                  <a:srgbClr val="5B6890"/>
+                </a:solidFill>
+                <a:latin typeface="Inter Medium Text Medium" pitchFamily="34" charset="0"/>
+                <a:ea typeface="Inter Medium Text Medium" pitchFamily="34" charset="-122"/>
+                <a:cs typeface="Inter Medium Text Medium" pitchFamily="34" charset="-120"/>
+              </a:rPr>
+              <a:t>CEN/TC 434 WG1</a:t>
+            </a:r>
+            <a:r>
+              <a:rPr lang="en-GB" sz="950" spc="100" dirty="0">
+                <a:solidFill>
+                  <a:srgbClr val="C2CADE"/>
+                </a:solidFill>
+                <a:latin typeface="Inter Text" pitchFamily="34" charset="0"/>
+                <a:ea typeface="Inter Text" pitchFamily="34" charset="-122"/>
+                <a:cs typeface="Inter Text" pitchFamily="34" charset="-120"/>
+              </a:rPr>
+              <a:t>   ·   </a:t>
+            </a:r>
+            <a:r>
+              <a:rPr lang="en-GB" sz="950" spc="100" dirty="0">
+                <a:solidFill>
+                  <a:srgbClr val="9AA4C2"/>
+                </a:solidFill>
+                <a:latin typeface="Inter Text" pitchFamily="34" charset="0"/>
+                <a:ea typeface="Inter Text" pitchFamily="34" charset="-122"/>
+                <a:cs typeface="Inter Text" pitchFamily="34" charset="-120"/>
+              </a:rPr>
+              <a:t>EN 16931-1:2026 amendment · Gross prices and rounding</a:t>
+            </a:r>
+          </a:p>
+        </p:txBody>
+      </p:sp>
+      <p:sp>
+        <p:nvSpPr>
+          <p:cNvPr id="4" name="SectionLabel 4"/>
+          <p:cNvSpPr txBox="1"/>
+          <p:nvPr/>
+        </p:nvSpPr>
+        <p:spPr>
+          <a:xfrm>
+            <a:off x="822960" y="868680"/>
+            <a:ext cx="8229600" cy="274320"/>
+          </a:xfrm>
+          <a:prstGeom prst="rect">
+            <a:avLst/>
+          </a:prstGeom>
+          <a:noFill/>
+          <a:ln/>
+        </p:spPr>
+        <p:txBody>
+          <a:bodyPr wrap="square" lIns="0" tIns="0" rIns="0" bIns="0" rtlCol="0" anchor="ctr"/>
+          <a:lstStyle/>
+          <a:p>
+            <a:pPr marL="0" indent="0" algn="l">
+              <a:buNone/>
+            </a:pPr>
+            <a:r>
+              <a:rPr lang="en-GB" sz="1100" spc="300" dirty="0">
+                <a:solidFill>
+                  <a:srgbClr val="19C3C8"/>
+                </a:solidFill>
+                <a:latin typeface="Inter SemiBold Text SemiBold" pitchFamily="34" charset="0"/>
+                <a:ea typeface="Inter SemiBold Text SemiBold" pitchFamily="34" charset="-122"/>
+                <a:cs typeface="Inter SemiBold Text SemiBold" pitchFamily="34" charset="-120"/>
+              </a:rPr>
+              <a:t>STATUS · 20 OCT 2026</a:t>
+            </a:r>
+          </a:p>
+        </p:txBody>
+      </p:sp>
+      <p:sp>
+        <p:nvSpPr>
+          <p:cNvPr id="5" name="Title 5"/>
+          <p:cNvSpPr txBox="1"/>
+          <p:nvPr/>
+        </p:nvSpPr>
+        <p:spPr>
+          <a:xfrm>
+            <a:off x="804672" y="1115568"/>
+            <a:ext cx="10424160" cy="822960"/>
+          </a:xfrm>
+          <a:prstGeom prst="rect">
+            <a:avLst/>
+          </a:prstGeom>
+          <a:noFill/>
+          <a:ln/>
+        </p:spPr>
+        <p:txBody>
+          <a:bodyPr wrap="square" lIns="0" tIns="0" rIns="0" bIns="0" rtlCol="0" anchor="t"/>
+          <a:lstStyle/>
+          <a:p>
+            <a:pPr marL="0" indent="0" algn="l">
+              <a:buNone/>
+            </a:pPr>
+            <a:r>
+              <a:rPr lang="en-GB" sz="3800" b="1" dirty="0">
+                <a:solidFill>
+                  <a:srgbClr val="1A2B5E"/>
+                </a:solidFill>
+                <a:latin typeface="Inter Text" pitchFamily="34" charset="0"/>
+                <a:ea typeface="Inter Text" pitchFamily="34" charset="-122"/>
+                <a:cs typeface="Inter Text" pitchFamily="34" charset="-120"/>
+              </a:rPr>
+              <a:t>Where the discussion stands</a:t>
+            </a:r>
+          </a:p>
+        </p:txBody>
+      </p:sp>
+      <p:sp>
+        <p:nvSpPr>
+          <p:cNvPr id="6" name="Tagline 6"/>
+          <p:cNvSpPr txBox="1"/>
+          <p:nvPr/>
+        </p:nvSpPr>
+        <p:spPr>
+          <a:xfrm>
+            <a:off x="822960" y="1865376"/>
+            <a:ext cx="10424160" cy="320040"/>
+          </a:xfrm>
+          <a:prstGeom prst="rect">
+            <a:avLst/>
+          </a:prstGeom>
+          <a:noFill/>
+          <a:ln/>
+        </p:spPr>
+        <p:txBody>
+          <a:bodyPr wrap="square" lIns="0" tIns="0" rIns="0" bIns="0" rtlCol="0" anchor="ctr"/>
+          <a:lstStyle/>
+          <a:p>
+            <a:pPr marL="0" indent="0" algn="l">
+              <a:buNone/>
+            </a:pPr>
+            <a:r>
+              <a:rPr lang="en-GB" sz="1300" dirty="0">
+                <a:solidFill>
+                  <a:srgbClr val="5B6890"/>
+                </a:solidFill>
+                <a:latin typeface="Inter Text" pitchFamily="34" charset="0"/>
+                <a:ea typeface="Inter Text" pitchFamily="34" charset="-122"/>
+                <a:cs typeface="Inter Text" pitchFamily="34" charset="-120"/>
+              </a:rPr>
+              <a:t>Much is agreed already — four points remain open.</a:t>
+            </a:r>
+          </a:p>
+        </p:txBody>
+      </p:sp>
+      <p:sp>
+        <p:nvSpPr>
+          <p:cNvPr id="7" name="PageNum 7"/>
+          <p:cNvSpPr txBox="1"/>
+          <p:nvPr/>
+        </p:nvSpPr>
+        <p:spPr>
+          <a:xfrm>
+            <a:off x="10908792" y="6514592"/>
+            <a:ext cx="822960" cy="292608"/>
+          </a:xfrm>
+          <a:prstGeom prst="rect">
+            <a:avLst/>
+          </a:prstGeom>
+          <a:noFill/>
+          <a:ln/>
+        </p:spPr>
+        <p:txBody>
+          <a:bodyPr wrap="square" lIns="0" tIns="0" rIns="0" bIns="0" rtlCol="0" anchor="ctr"/>
+          <a:lstStyle/>
+          <a:p>
+            <a:pPr marL="0" indent="0" algn="r">
+              <a:buNone/>
+            </a:pPr>
+            <a:fld id="{67D73E2F-A595-473C-9F0C-80BA506D5B08}" type="slidenum">
+              <a:rPr lang="en-GB" sz="1000" spc="200" dirty="0">
+                <a:solidFill>
+                  <a:srgbClr val="5B6890"/>
+                </a:solidFill>
+                <a:latin typeface="Inter SemiBold Text SemiBold" pitchFamily="34" charset="0"/>
+                <a:ea typeface="Inter SemiBold Text SemiBold" pitchFamily="34" charset="-122"/>
+                <a:cs typeface="Inter SemiBold Text SemiBold" pitchFamily="34" charset="-120"/>
+              </a:rPr>
+              <a:t>19</a:t>
+            </a:fld>
+            <a:endParaRPr lang="en-GB" sz="1000" spc="200" dirty="0">
+              <a:solidFill>
+                <a:srgbClr val="5B6890"/>
+              </a:solidFill>
+              <a:latin typeface="Inter SemiBold Text SemiBold" pitchFamily="34" charset="0"/>
+              <a:ea typeface="Inter SemiBold Text SemiBold" pitchFamily="34" charset="-122"/>
+              <a:cs typeface="Inter SemiBold Text SemiBold" pitchFamily="34" charset="-120"/>
+            </a:endParaRPr>
+          </a:p>
+        </p:txBody>
+      </p:sp>
+      <p:sp>
+        <p:nvSpPr>
+          <p:cNvPr id="8" name="Card 8"/>
+          <p:cNvSpPr/>
+          <p:nvPr/>
+        </p:nvSpPr>
+        <p:spPr>
+          <a:xfrm>
+            <a:off x="822960" y="2331720"/>
+            <a:ext cx="5166360" cy="1691640"/>
+          </a:xfrm>
+          <a:prstGeom prst="roundRect">
+            <a:avLst>
+              <a:gd name="adj" fmla="val 4324"/>
+            </a:avLst>
+          </a:prstGeom>
+          <a:solidFill>
+            <a:srgbClr val="FFFFFF"/>
+          </a:solidFill>
+          <a:ln w="12700">
+            <a:solidFill>
+              <a:srgbClr val="E2E7F2"/>
+            </a:solidFill>
+            <a:prstDash val="solid"/>
+          </a:ln>
+          <a:effectLst>
+            <a:outerShdw blurRad="101600" dist="38100" dir="5400000" algn="bl" rotWithShape="0">
+              <a:srgbClr val="0A1230">
+                <a:alpha val="8000"/>
+              </a:srgbClr>
+            </a:outerShdw>
+          </a:effectLst>
+        </p:spPr>
+        <p:txBody>
+          <a:bodyPr/>
+          <a:lstStyle/>
+          <a:p>
+            <a:endParaRPr lang="en-GB"/>
+          </a:p>
+        </p:txBody>
+      </p:sp>
+      <p:sp>
+        <p:nvSpPr>
+          <p:cNvPr id="9" name="IconCircle 9"/>
+          <p:cNvSpPr/>
+          <p:nvPr/>
+        </p:nvSpPr>
+        <p:spPr>
+          <a:xfrm>
+            <a:off x="1060704" y="2532888"/>
+            <a:ext cx="402336" cy="402336"/>
+          </a:xfrm>
+          <a:prstGeom prst="ellipse">
+            <a:avLst/>
+          </a:prstGeom>
+          <a:solidFill>
+            <a:srgbClr val="19C3C8"/>
+          </a:solidFill>
+          <a:ln>
+            <a:noFill/>
+          </a:ln>
+          <a:effectLst>
+            <a:outerShdw blurRad="88900" dist="38100" dir="5400000" algn="bl" rotWithShape="0">
+              <a:srgbClr val="0A1230">
+                <a:alpha val="18000"/>
+              </a:srgbClr>
+            </a:outerShdw>
+          </a:effectLst>
+        </p:spPr>
+        <p:txBody>
+          <a:bodyPr/>
+          <a:lstStyle/>
+          <a:p>
+            <a:endParaRPr lang="en-GB"/>
+          </a:p>
+        </p:txBody>
+      </p:sp>
+      <p:pic>
+        <p:nvPicPr>
+          <p:cNvPr id="10" name="Icon 10"/>
+          <p:cNvPicPr>
+            <a:picLocks noChangeAspect="1"/>
+          </p:cNvPicPr>
+          <p:nvPr/>
+        </p:nvPicPr>
+        <p:blipFill>
+          <a:blip r:embed="rId2"/>
+          <a:stretch>
+            <a:fillRect/>
+          </a:stretch>
+        </p:blipFill>
+        <p:spPr>
+          <a:xfrm>
+            <a:off x="1171346" y="2643530"/>
+            <a:ext cx="181051" cy="181051"/>
+          </a:xfrm>
+          <a:prstGeom prst="rect">
+            <a:avLst/>
+          </a:prstGeom>
+        </p:spPr>
+      </p:pic>
+      <p:sp>
+        <p:nvSpPr>
+          <p:cNvPr id="11" name="Text 11"/>
+          <p:cNvSpPr txBox="1"/>
+          <p:nvPr/>
+        </p:nvSpPr>
+        <p:spPr>
+          <a:xfrm>
+            <a:off x="1600200" y="2514600"/>
+            <a:ext cx="4206240" cy="438912"/>
+          </a:xfrm>
+          <a:prstGeom prst="rect">
+            <a:avLst/>
+          </a:prstGeom>
+          <a:noFill/>
+          <a:ln/>
+        </p:spPr>
+        <p:txBody>
+          <a:bodyPr wrap="square" lIns="0" tIns="0" rIns="0" bIns="0" rtlCol="0" anchor="ctr"/>
+          <a:lstStyle/>
+          <a:p>
+            <a:pPr marL="0" indent="0" algn="l">
+              <a:buNone/>
+            </a:pPr>
+            <a:r>
+              <a:rPr lang="en-GB" sz="1500" dirty="0">
+                <a:solidFill>
+                  <a:srgbClr val="1A2B5E"/>
+                </a:solidFill>
+                <a:latin typeface="Inter SemiBold Text SemiBold" pitchFamily="34" charset="0"/>
+                <a:ea typeface="Inter SemiBold Text SemiBold" pitchFamily="34" charset="-122"/>
+                <a:cs typeface="Inter SemiBold Text SemiBold" pitchFamily="34" charset="-120"/>
+              </a:rPr>
+              <a:t>Where the proposals meet</a:t>
+            </a:r>
+          </a:p>
+        </p:txBody>
+      </p:sp>
+      <p:sp>
+        <p:nvSpPr>
+          <p:cNvPr id="12" name="Text 12"/>
+          <p:cNvSpPr txBox="1"/>
+          <p:nvPr/>
+        </p:nvSpPr>
+        <p:spPr>
+          <a:xfrm>
+            <a:off x="1133856" y="2990088"/>
+            <a:ext cx="4663440" cy="1005840"/>
+          </a:xfrm>
+          <a:prstGeom prst="rect">
+            <a:avLst/>
+          </a:prstGeom>
+          <a:noFill/>
+          <a:ln/>
+        </p:spPr>
+        <p:txBody>
+          <a:bodyPr wrap="square" lIns="0" tIns="0" rIns="0" bIns="0" rtlCol="0" anchor="t"/>
+          <a:lstStyle/>
+          <a:p>
+            <a:pPr marL="164592" indent="-164592" algn="l">
+              <a:spcAft>
+                <a:spcPts val="200"/>
+              </a:spcAft>
+              <a:buSzPct val="100000"/>
+              <a:buChar char="•"/>
+            </a:pPr>
+            <a:r>
+              <a:rPr lang="en-GB" sz="1200" dirty="0">
+                <a:solidFill>
+                  <a:srgbClr val="5B6890"/>
+                </a:solidFill>
+                <a:latin typeface="Inter Text" pitchFamily="34" charset="0"/>
+                <a:ea typeface="Inter Text" pitchFamily="34" charset="-122"/>
+                <a:cs typeface="Inter Text" pitchFamily="34" charset="-120"/>
+              </a:rPr>
+              <a:t>VAT in the Minor Unit, rounded once per VAT category</a:t>
+            </a:r>
+          </a:p>
+          <a:p>
+            <a:pPr marL="164592" indent="-164592" algn="l">
+              <a:spcAft>
+                <a:spcPts val="200"/>
+              </a:spcAft>
+              <a:buSzPct val="100000"/>
+              <a:buChar char="•"/>
+            </a:pPr>
+            <a:r>
+              <a:rPr lang="en-GB" sz="1200" dirty="0">
+                <a:solidFill>
+                  <a:srgbClr val="5B6890"/>
+                </a:solidFill>
+                <a:latin typeface="Inter Text" pitchFamily="34" charset="0"/>
+                <a:ea typeface="Inter Text" pitchFamily="34" charset="-122"/>
+                <a:cs typeface="Inter Text" pitchFamily="34" charset="-120"/>
+              </a:rPr>
+              <a:t>“Plus VAT” terms and an indicator in the core</a:t>
+            </a:r>
+          </a:p>
+          <a:p>
+            <a:pPr marL="164592" indent="-164592" algn="l">
+              <a:spcAft>
+                <a:spcPts val="200"/>
+              </a:spcAft>
+              <a:buSzPct val="100000"/>
+              <a:buChar char="•"/>
+            </a:pPr>
+            <a:r>
+              <a:rPr lang="en-GB" sz="1200" dirty="0">
+                <a:solidFill>
+                  <a:srgbClr val="5B6890"/>
+                </a:solidFill>
+                <a:latin typeface="Inter Text" pitchFamily="34" charset="0"/>
+                <a:ea typeface="Inter Text" pitchFamily="34" charset="-122"/>
+                <a:cs typeface="Inter Text" pitchFamily="34" charset="-120"/>
+              </a:rPr>
+              <a:t>Precise line values and more price decimals than today</a:t>
+            </a:r>
+          </a:p>
+          <a:p>
+            <a:pPr marL="164592" indent="-164592" algn="l">
+              <a:spcAft>
+                <a:spcPts val="200"/>
+              </a:spcAft>
+              <a:buSzPct val="100000"/>
+              <a:buChar char="•"/>
+            </a:pPr>
+            <a:r>
+              <a:rPr lang="en-GB" sz="1200" dirty="0">
+                <a:solidFill>
+                  <a:srgbClr val="5B6890"/>
+                </a:solidFill>
+                <a:latin typeface="Inter Text" pitchFamily="34" charset="0"/>
+                <a:ea typeface="Inter Text" pitchFamily="34" charset="-122"/>
+                <a:cs typeface="Inter Text" pitchFamily="34" charset="-120"/>
+              </a:rPr>
+              <a:t>Proposed by </a:t>
+            </a:r>
+            <a:r>
+              <a:rPr lang="en-GB" sz="1200" dirty="0">
+                <a:solidFill>
+                  <a:srgbClr val="5B6890"/>
+                </a:solidFill>
+                <a:latin typeface="Inter Text" pitchFamily="34" charset="0"/>
+                <a:ea typeface="Inter Text" pitchFamily="34" charset="-122"/>
+                <a:cs typeface="Inter Text" pitchFamily="34" charset="-120"/>
+                <a:hlinkClick r:id="rId11">
+                  <a:extLst>
+                    <a:ext uri="{A12FA001-AC4F-418D-AE19-62706E023703}">
+                      <ahyp:hlinkClr xmlns:ahyp="http://schemas.microsoft.com/office/drawing/2018/hyperlinkcolor" val="tx"/>
+                    </a:ext>
+                  </a:extLst>
+                </a:hlinkClick>
+              </a:rPr>
+              <a:t>Paul Simons</a:t>
+            </a:r>
+            <a:r>
+              <a:rPr lang="en-GB" sz="1200" dirty="0">
+                <a:solidFill>
+                  <a:srgbClr val="5B6890"/>
+                </a:solidFill>
+                <a:latin typeface="Inter Text" pitchFamily="34" charset="0"/>
+                <a:ea typeface="Inter Text" pitchFamily="34" charset="-122"/>
+                <a:cs typeface="Inter Text" pitchFamily="34" charset="-120"/>
+              </a:rPr>
+              <a:t> and </a:t>
+            </a:r>
+            <a:r>
+              <a:rPr lang="en-GB" sz="1200" dirty="0">
+                <a:solidFill>
+                  <a:srgbClr val="5B6890"/>
+                </a:solidFill>
+                <a:latin typeface="Inter Text" pitchFamily="34" charset="0"/>
+                <a:ea typeface="Inter Text" pitchFamily="34" charset="-122"/>
+                <a:cs typeface="Inter Text" pitchFamily="34" charset="-120"/>
+                <a:hlinkClick r:id="rId12">
+                  <a:extLst>
+                    <a:ext uri="{A12FA001-AC4F-418D-AE19-62706E023703}">
+                      <ahyp:hlinkClr xmlns:ahyp="http://schemas.microsoft.com/office/drawing/2018/hyperlinkcolor" val="tx"/>
+                    </a:ext>
+                  </a:extLst>
+                </a:hlinkClick>
+              </a:rPr>
+              <a:t>Cyrille Sautereau</a:t>
+            </a:r>
+            <a:r>
+              <a:rPr lang="en-GB" sz="1200" dirty="0">
+                <a:solidFill>
+                  <a:srgbClr val="5B6890"/>
+                </a:solidFill>
+                <a:latin typeface="Inter Text" pitchFamily="34" charset="0"/>
+                <a:ea typeface="Inter Text" pitchFamily="34" charset="-122"/>
+                <a:cs typeface="Inter Text" pitchFamily="34" charset="-120"/>
+              </a:rPr>
+              <a:t>, 16–19 Oct</a:t>
+            </a:r>
+          </a:p>
+        </p:txBody>
+      </p:sp>
+      <p:sp>
+        <p:nvSpPr>
+          <p:cNvPr id="13" name="Card 13"/>
+          <p:cNvSpPr/>
+          <p:nvPr/>
+        </p:nvSpPr>
+        <p:spPr>
+          <a:xfrm>
+            <a:off x="822960" y="4160520"/>
+            <a:ext cx="5166360" cy="1645920"/>
+          </a:xfrm>
+          <a:prstGeom prst="roundRect">
+            <a:avLst>
+              <a:gd name="adj" fmla="val 4444"/>
+            </a:avLst>
+          </a:prstGeom>
+          <a:solidFill>
+            <a:srgbClr val="FFFFFF"/>
+          </a:solidFill>
+          <a:ln w="12700">
+            <a:solidFill>
+              <a:srgbClr val="E2E7F2"/>
+            </a:solidFill>
+            <a:prstDash val="solid"/>
+          </a:ln>
+          <a:effectLst>
+            <a:outerShdw blurRad="101600" dist="38100" dir="5400000" algn="bl" rotWithShape="0">
+              <a:srgbClr val="0A1230">
+                <a:alpha val="8000"/>
+              </a:srgbClr>
+            </a:outerShdw>
+          </a:effectLst>
+        </p:spPr>
+        <p:txBody>
+          <a:bodyPr/>
+          <a:lstStyle/>
+          <a:p>
+            <a:endParaRPr lang="en-GB"/>
+          </a:p>
+        </p:txBody>
+      </p:sp>
+      <p:sp>
+        <p:nvSpPr>
+          <p:cNvPr id="14" name="IconCircle 14"/>
+          <p:cNvSpPr/>
+          <p:nvPr/>
+        </p:nvSpPr>
+        <p:spPr>
+          <a:xfrm>
+            <a:off x="1060704" y="4361688"/>
+            <a:ext cx="402336" cy="402336"/>
+          </a:xfrm>
+          <a:prstGeom prst="ellipse">
+            <a:avLst/>
+          </a:prstGeom>
+          <a:solidFill>
+            <a:srgbClr val="1A2B5E"/>
+          </a:solidFill>
+          <a:ln>
+            <a:noFill/>
+          </a:ln>
+          <a:effectLst>
+            <a:outerShdw blurRad="88900" dist="38100" dir="5400000" algn="bl" rotWithShape="0">
+              <a:srgbClr val="0A1230">
+                <a:alpha val="18000"/>
+              </a:srgbClr>
+            </a:outerShdw>
+          </a:effectLst>
+        </p:spPr>
+        <p:txBody>
+          <a:bodyPr/>
+          <a:lstStyle/>
+          <a:p>
+            <a:endParaRPr lang="en-GB"/>
+          </a:p>
+        </p:txBody>
+      </p:sp>
+      <p:pic>
+        <p:nvPicPr>
+          <p:cNvPr id="15" name="Icon 15"/>
+          <p:cNvPicPr>
+            <a:picLocks noChangeAspect="1"/>
+          </p:cNvPicPr>
+          <p:nvPr/>
+        </p:nvPicPr>
+        <p:blipFill>
+          <a:blip r:embed="rId3"/>
+          <a:stretch>
+            <a:fillRect/>
+          </a:stretch>
+        </p:blipFill>
+        <p:spPr>
+          <a:xfrm>
+            <a:off x="1171346" y="4472330"/>
+            <a:ext cx="181051" cy="181051"/>
+          </a:xfrm>
+          <a:prstGeom prst="rect">
+            <a:avLst/>
+          </a:prstGeom>
+        </p:spPr>
+      </p:pic>
+      <p:sp>
+        <p:nvSpPr>
+          <p:cNvPr id="16" name="Text 16"/>
+          <p:cNvSpPr txBox="1"/>
+          <p:nvPr/>
+        </p:nvSpPr>
+        <p:spPr>
+          <a:xfrm>
+            <a:off x="1600200" y="4343400"/>
+            <a:ext cx="4206240" cy="438912"/>
+          </a:xfrm>
+          <a:prstGeom prst="rect">
+            <a:avLst/>
+          </a:prstGeom>
+          <a:noFill/>
+          <a:ln/>
+        </p:spPr>
+        <p:txBody>
+          <a:bodyPr wrap="square" lIns="0" tIns="0" rIns="0" bIns="0" rtlCol="0" anchor="ctr"/>
+          <a:lstStyle/>
+          <a:p>
+            <a:pPr marL="0" indent="0" algn="l">
+              <a:buNone/>
+            </a:pPr>
+            <a:r>
+              <a:rPr lang="en-GB" sz="1500" dirty="0">
+                <a:solidFill>
+                  <a:srgbClr val="1A2B5E"/>
+                </a:solidFill>
+                <a:latin typeface="Inter SemiBold Text SemiBold" pitchFamily="34" charset="0"/>
+                <a:ea typeface="Inter SemiBold Text SemiBold" pitchFamily="34" charset="-122"/>
+                <a:cs typeface="Inter SemiBold Text SemiBold" pitchFamily="34" charset="-120"/>
+              </a:rPr>
+              <a:t>Still open</a:t>
+            </a:r>
+          </a:p>
+        </p:txBody>
+      </p:sp>
+      <p:sp>
+        <p:nvSpPr>
+          <p:cNvPr id="17" name="Text 17"/>
+          <p:cNvSpPr txBox="1"/>
+          <p:nvPr/>
+        </p:nvSpPr>
+        <p:spPr>
+          <a:xfrm>
+            <a:off x="1133856" y="4818888"/>
+            <a:ext cx="4663440" cy="960120"/>
+          </a:xfrm>
+          <a:prstGeom prst="rect">
+            <a:avLst/>
+          </a:prstGeom>
+          <a:noFill/>
+          <a:ln/>
+        </p:spPr>
+        <p:txBody>
+          <a:bodyPr wrap="square" lIns="0" tIns="0" rIns="0" bIns="0" rtlCol="0" anchor="t"/>
+          <a:lstStyle/>
+          <a:p>
+            <a:pPr marL="164592" indent="-164592" algn="l">
+              <a:spcAft>
+                <a:spcPts val="200"/>
+              </a:spcAft>
+              <a:buSzPct val="100000"/>
+              <a:buChar char="•"/>
+            </a:pPr>
+            <a:r>
+              <a:rPr lang="en-GB" sz="1200" dirty="0">
+                <a:solidFill>
+                  <a:srgbClr val="5B6890"/>
+                </a:solidFill>
+                <a:latin typeface="Inter Text" pitchFamily="34" charset="0"/>
+                <a:ea typeface="Inter Text" pitchFamily="34" charset="-122"/>
+                <a:cs typeface="Inter Text" pitchFamily="34" charset="-120"/>
+              </a:rPr>
+              <a:t>One line amount, or a second precise one (BT-131NR)</a:t>
+            </a:r>
+          </a:p>
+          <a:p>
+            <a:pPr marL="164592" indent="-164592" algn="l">
+              <a:spcAft>
+                <a:spcPts val="200"/>
+              </a:spcAft>
+              <a:buSzPct val="100000"/>
+              <a:buChar char="•"/>
+            </a:pPr>
+            <a:r>
+              <a:rPr lang="en-GB" sz="1200" dirty="0">
+                <a:solidFill>
+                  <a:srgbClr val="5B6890"/>
+                </a:solidFill>
+                <a:latin typeface="Inter Text" pitchFamily="34" charset="0"/>
+                <a:ea typeface="Inter Text" pitchFamily="34" charset="-122"/>
+                <a:cs typeface="Inter Text" pitchFamily="34" charset="-120"/>
+              </a:rPr>
+              <a:t>A maximum of 8 decimals, or none</a:t>
+            </a:r>
+          </a:p>
+          <a:p>
+            <a:pPr marL="164592" indent="-164592" algn="l">
+              <a:spcAft>
+                <a:spcPts val="200"/>
+              </a:spcAft>
+              <a:buSzPct val="100000"/>
+              <a:buChar char="•"/>
+            </a:pPr>
+            <a:r>
+              <a:rPr lang="en-GB" sz="1200" dirty="0">
+                <a:solidFill>
+                  <a:srgbClr val="5B6890"/>
+                </a:solidFill>
+                <a:latin typeface="Inter Text" pitchFamily="34" charset="0"/>
+                <a:ea typeface="Inter Text" pitchFamily="34" charset="-122"/>
+                <a:cs typeface="Inter Text" pitchFamily="34" charset="-120"/>
+              </a:rPr>
+              <a:t>BT-116 VAT category taxable amount: exact, or in cents</a:t>
+            </a:r>
+          </a:p>
+          <a:p>
+            <a:pPr marL="164592" indent="-164592" algn="l">
+              <a:spcAft>
+                <a:spcPts val="200"/>
+              </a:spcAft>
+              <a:buSzPct val="100000"/>
+              <a:buChar char="•"/>
+            </a:pPr>
+            <a:r>
+              <a:rPr lang="en-GB" sz="1200" dirty="0">
+                <a:solidFill>
+                  <a:srgbClr val="5B6890"/>
+                </a:solidFill>
+                <a:latin typeface="Inter Text" pitchFamily="34" charset="0"/>
+                <a:ea typeface="Inter Text" pitchFamily="34" charset="-122"/>
+                <a:cs typeface="Inter Text" pitchFamily="34" charset="-120"/>
+              </a:rPr>
+              <a:t>VAT first: a rule in the core, or guidance and CIUS</a:t>
+            </a:r>
+          </a:p>
+        </p:txBody>
+      </p:sp>
+      <p:sp>
+        <p:nvSpPr>
+          <p:cNvPr id="18" name="Panel 18"/>
+          <p:cNvSpPr/>
+          <p:nvPr/>
+        </p:nvSpPr>
+        <p:spPr>
+          <a:xfrm>
+            <a:off x="6172200" y="2331720"/>
+            <a:ext cx="5193792" cy="3474720"/>
+          </a:xfrm>
+          <a:prstGeom prst="roundRect">
+            <a:avLst>
+              <a:gd name="adj" fmla="val 2631"/>
+            </a:avLst>
+          </a:prstGeom>
+          <a:solidFill>
+            <a:srgbClr val="1A2B5E"/>
+          </a:solidFill>
+          <a:ln>
+            <a:noFill/>
+          </a:ln>
+          <a:effectLst>
+            <a:outerShdw blurRad="101600" dist="38100" dir="5400000" algn="bl" rotWithShape="0">
+              <a:srgbClr val="0A1230">
+                <a:alpha val="18000"/>
+              </a:srgbClr>
+            </a:outerShdw>
+          </a:effectLst>
+        </p:spPr>
+        <p:txBody>
+          <a:bodyPr/>
+          <a:lstStyle/>
+          <a:p>
+            <a:endParaRPr lang="en-GB"/>
+          </a:p>
+        </p:txBody>
+      </p:sp>
+      <p:sp>
+        <p:nvSpPr>
+          <p:cNvPr id="19" name="Text 19"/>
+          <p:cNvSpPr txBox="1"/>
+          <p:nvPr/>
+        </p:nvSpPr>
+        <p:spPr>
+          <a:xfrm>
+            <a:off x="6492240" y="2514600"/>
+            <a:ext cx="4572000" cy="274320"/>
+          </a:xfrm>
+          <a:prstGeom prst="rect">
+            <a:avLst/>
+          </a:prstGeom>
+          <a:noFill/>
+          <a:ln/>
+        </p:spPr>
+        <p:txBody>
+          <a:bodyPr wrap="square" lIns="0" tIns="0" rIns="0" bIns="0" rtlCol="0" anchor="ctr"/>
+          <a:lstStyle/>
+          <a:p>
+            <a:pPr marL="0" indent="0" algn="l">
+              <a:buNone/>
+            </a:pPr>
+            <a:r>
+              <a:rPr lang="en-GB" sz="1100" spc="300" dirty="0">
+                <a:solidFill>
+                  <a:srgbClr val="19C3C8"/>
+                </a:solidFill>
+                <a:latin typeface="Inter SemiBold Text SemiBold" pitchFamily="34" charset="0"/>
+                <a:ea typeface="Inter SemiBold Text SemiBold" pitchFamily="34" charset="-122"/>
+                <a:cs typeface="Inter SemiBold Text SemiBold" pitchFamily="34" charset="-120"/>
+              </a:rPr>
+              <a:t>IN THE END: ACCURATE DATA FOR ALL</a:t>
+            </a:r>
+          </a:p>
+        </p:txBody>
+      </p:sp>
+      <p:sp>
+        <p:nvSpPr>
+          <p:cNvPr id="20" name="Shape 20"/>
+          <p:cNvSpPr/>
+          <p:nvPr/>
+        </p:nvSpPr>
+        <p:spPr>
+          <a:xfrm>
+            <a:off x="6492240" y="2944368"/>
+            <a:ext cx="292608" cy="292608"/>
+          </a:xfrm>
+          <a:prstGeom prst="ellipse">
+            <a:avLst/>
+          </a:prstGeom>
+          <a:solidFill>
+            <a:srgbClr val="19C3C8"/>
+          </a:solidFill>
+          <a:ln>
+            <a:noFill/>
+          </a:ln>
+        </p:spPr>
+        <p:txBody>
+          <a:bodyPr/>
+          <a:lstStyle/>
+          <a:p>
+            <a:endParaRPr lang="en-GB"/>
+          </a:p>
+        </p:txBody>
+      </p:sp>
+      <p:sp>
+        <p:nvSpPr>
+          <p:cNvPr id="21" name="Text 21"/>
+          <p:cNvSpPr txBox="1"/>
+          <p:nvPr/>
+        </p:nvSpPr>
+        <p:spPr>
+          <a:xfrm>
+            <a:off x="6492240" y="2944368"/>
+            <a:ext cx="292608" cy="292608"/>
+          </a:xfrm>
+          <a:prstGeom prst="rect">
+            <a:avLst/>
+          </a:prstGeom>
+          <a:noFill/>
+          <a:ln/>
+        </p:spPr>
+        <p:txBody>
+          <a:bodyPr wrap="square" lIns="0" tIns="0" rIns="0" bIns="0" rtlCol="0" anchor="ctr"/>
+          <a:lstStyle/>
+          <a:p>
+            <a:pPr marL="0" indent="0" algn="ctr">
+              <a:buNone/>
+            </a:pPr>
+            <a:r>
+              <a:rPr lang="en-GB" sz="1200" dirty="0">
+                <a:solidFill>
+                  <a:srgbClr val="1A2B5E"/>
+                </a:solidFill>
+                <a:latin typeface="Inter SemiBold Text SemiBold" pitchFamily="34" charset="0"/>
+                <a:ea typeface="Inter SemiBold Text SemiBold" pitchFamily="34" charset="-122"/>
+                <a:cs typeface="Inter SemiBold Text SemiBold" pitchFamily="34" charset="-120"/>
+              </a:rPr>
+              <a:t>✓</a:t>
+            </a:r>
+          </a:p>
+        </p:txBody>
+      </p:sp>
+      <p:sp>
+        <p:nvSpPr>
+          <p:cNvPr id="22" name="Text 22"/>
+          <p:cNvSpPr txBox="1"/>
+          <p:nvPr/>
+        </p:nvSpPr>
+        <p:spPr>
+          <a:xfrm>
+            <a:off x="6949440" y="2880360"/>
+            <a:ext cx="4251960" cy="420624"/>
+          </a:xfrm>
+          <a:prstGeom prst="rect">
+            <a:avLst/>
+          </a:prstGeom>
+          <a:noFill/>
+          <a:ln/>
+        </p:spPr>
+        <p:txBody>
+          <a:bodyPr wrap="square" lIns="0" tIns="0" rIns="0" bIns="0" rtlCol="0" anchor="ctr"/>
+          <a:lstStyle/>
+          <a:p>
+            <a:pPr marL="0" indent="0" algn="l">
+              <a:lnSpc>
+                <a:spcPct val="105000"/>
+              </a:lnSpc>
+              <a:buNone/>
+            </a:pPr>
+            <a:r>
+              <a:rPr lang="en-GB" sz="1250" dirty="0">
+                <a:solidFill>
+                  <a:srgbClr val="FFFFFF"/>
+                </a:solidFill>
+                <a:latin typeface="Inter Text" pitchFamily="34" charset="0"/>
+                <a:ea typeface="Inter Text" pitchFamily="34" charset="-122"/>
+                <a:cs typeface="Inter Text" pitchFamily="34" charset="-120"/>
+              </a:rPr>
+              <a:t>Conformant to the EN and compliant with national VAT law</a:t>
+            </a:r>
+          </a:p>
+        </p:txBody>
+      </p:sp>
+      <p:sp>
+        <p:nvSpPr>
+          <p:cNvPr id="23" name="Shape 23"/>
+          <p:cNvSpPr/>
+          <p:nvPr/>
+        </p:nvSpPr>
+        <p:spPr>
+          <a:xfrm>
+            <a:off x="6492240" y="3511296"/>
+            <a:ext cx="292608" cy="292608"/>
+          </a:xfrm>
+          <a:prstGeom prst="ellipse">
+            <a:avLst/>
+          </a:prstGeom>
+          <a:solidFill>
+            <a:srgbClr val="19C3C8"/>
+          </a:solidFill>
+          <a:ln>
+            <a:noFill/>
+          </a:ln>
+        </p:spPr>
+        <p:txBody>
+          <a:bodyPr/>
+          <a:lstStyle/>
+          <a:p>
+            <a:endParaRPr lang="en-GB"/>
+          </a:p>
+        </p:txBody>
+      </p:sp>
+      <p:sp>
+        <p:nvSpPr>
+          <p:cNvPr id="24" name="Text 24"/>
+          <p:cNvSpPr txBox="1"/>
+          <p:nvPr/>
+        </p:nvSpPr>
+        <p:spPr>
+          <a:xfrm>
+            <a:off x="6492240" y="3511296"/>
+            <a:ext cx="292608" cy="292608"/>
+          </a:xfrm>
+          <a:prstGeom prst="rect">
+            <a:avLst/>
+          </a:prstGeom>
+          <a:noFill/>
+          <a:ln/>
+        </p:spPr>
+        <p:txBody>
+          <a:bodyPr wrap="square" lIns="0" tIns="0" rIns="0" bIns="0" rtlCol="0" anchor="ctr"/>
+          <a:lstStyle/>
+          <a:p>
+            <a:pPr marL="0" indent="0" algn="ctr">
+              <a:buNone/>
+            </a:pPr>
+            <a:r>
+              <a:rPr lang="en-GB" sz="1200" dirty="0">
+                <a:solidFill>
+                  <a:srgbClr val="1A2B5E"/>
+                </a:solidFill>
+                <a:latin typeface="Inter SemiBold Text SemiBold" pitchFamily="34" charset="0"/>
+                <a:ea typeface="Inter SemiBold Text SemiBold" pitchFamily="34" charset="-122"/>
+                <a:cs typeface="Inter SemiBold Text SemiBold" pitchFamily="34" charset="-120"/>
+              </a:rPr>
+              <a:t>✓</a:t>
+            </a:r>
+          </a:p>
+        </p:txBody>
+      </p:sp>
+      <p:sp>
+        <p:nvSpPr>
+          <p:cNvPr id="25" name="Text 25"/>
+          <p:cNvSpPr txBox="1"/>
+          <p:nvPr/>
+        </p:nvSpPr>
+        <p:spPr>
+          <a:xfrm>
+            <a:off x="6949440" y="3447288"/>
+            <a:ext cx="4251960" cy="420624"/>
+          </a:xfrm>
+          <a:prstGeom prst="rect">
+            <a:avLst/>
+          </a:prstGeom>
+          <a:noFill/>
+          <a:ln/>
+        </p:spPr>
+        <p:txBody>
+          <a:bodyPr wrap="square" lIns="0" tIns="0" rIns="0" bIns="0" rtlCol="0" anchor="ctr"/>
+          <a:lstStyle/>
+          <a:p>
+            <a:pPr marL="0" indent="0" algn="l">
+              <a:lnSpc>
+                <a:spcPct val="105000"/>
+              </a:lnSpc>
+              <a:buNone/>
+            </a:pPr>
+            <a:r>
+              <a:rPr lang="en-GB" sz="1250" dirty="0">
+                <a:solidFill>
+                  <a:srgbClr val="FFFFFF"/>
+                </a:solidFill>
+                <a:latin typeface="Inter Text" pitchFamily="34" charset="0"/>
+                <a:ea typeface="Inter Text" pitchFamily="34" charset="-122"/>
+                <a:cs typeface="Inter Text" pitchFamily="34" charset="-120"/>
+              </a:rPr>
+              <a:t>A tolerance for those who accept it, no barrier for others</a:t>
+            </a:r>
+          </a:p>
+        </p:txBody>
+      </p:sp>
+      <p:sp>
+        <p:nvSpPr>
+          <p:cNvPr id="26" name="Shape 26"/>
+          <p:cNvSpPr/>
+          <p:nvPr/>
+        </p:nvSpPr>
+        <p:spPr>
+          <a:xfrm>
+            <a:off x="6492240" y="4078224"/>
+            <a:ext cx="292608" cy="292608"/>
+          </a:xfrm>
+          <a:prstGeom prst="ellipse">
+            <a:avLst/>
+          </a:prstGeom>
+          <a:solidFill>
+            <a:srgbClr val="19C3C8"/>
+          </a:solidFill>
+          <a:ln>
+            <a:noFill/>
+          </a:ln>
+        </p:spPr>
+        <p:txBody>
+          <a:bodyPr/>
+          <a:lstStyle/>
+          <a:p>
+            <a:endParaRPr lang="en-GB"/>
+          </a:p>
+        </p:txBody>
+      </p:sp>
+      <p:sp>
+        <p:nvSpPr>
+          <p:cNvPr id="27" name="Text 27"/>
+          <p:cNvSpPr txBox="1"/>
+          <p:nvPr/>
+        </p:nvSpPr>
+        <p:spPr>
+          <a:xfrm>
+            <a:off x="6492240" y="4078224"/>
+            <a:ext cx="292608" cy="292608"/>
+          </a:xfrm>
+          <a:prstGeom prst="rect">
+            <a:avLst/>
+          </a:prstGeom>
+          <a:noFill/>
+          <a:ln/>
+        </p:spPr>
+        <p:txBody>
+          <a:bodyPr wrap="square" lIns="0" tIns="0" rIns="0" bIns="0" rtlCol="0" anchor="ctr"/>
+          <a:lstStyle/>
+          <a:p>
+            <a:pPr marL="0" indent="0" algn="ctr">
+              <a:buNone/>
+            </a:pPr>
+            <a:r>
+              <a:rPr lang="en-GB" sz="1200" dirty="0">
+                <a:solidFill>
+                  <a:srgbClr val="1A2B5E"/>
+                </a:solidFill>
+                <a:latin typeface="Inter SemiBold Text SemiBold" pitchFamily="34" charset="0"/>
+                <a:ea typeface="Inter SemiBold Text SemiBold" pitchFamily="34" charset="-122"/>
+                <a:cs typeface="Inter SemiBold Text SemiBold" pitchFamily="34" charset="-120"/>
+              </a:rPr>
+              <a:t>✓</a:t>
+            </a:r>
+          </a:p>
+        </p:txBody>
+      </p:sp>
+      <p:sp>
+        <p:nvSpPr>
+          <p:cNvPr id="28" name="Text 28"/>
+          <p:cNvSpPr txBox="1"/>
+          <p:nvPr/>
+        </p:nvSpPr>
+        <p:spPr>
+          <a:xfrm>
+            <a:off x="6949440" y="4014216"/>
+            <a:ext cx="4251960" cy="420624"/>
+          </a:xfrm>
+          <a:prstGeom prst="rect">
+            <a:avLst/>
+          </a:prstGeom>
+          <a:noFill/>
+          <a:ln/>
+        </p:spPr>
+        <p:txBody>
+          <a:bodyPr wrap="square" lIns="0" tIns="0" rIns="0" bIns="0" rtlCol="0" anchor="ctr"/>
+          <a:lstStyle/>
+          <a:p>
+            <a:pPr marL="0" indent="0" algn="l">
+              <a:lnSpc>
+                <a:spcPct val="105000"/>
+              </a:lnSpc>
+              <a:buNone/>
+            </a:pPr>
+            <a:r>
+              <a:rPr lang="en-GB" sz="1250" dirty="0">
+                <a:solidFill>
+                  <a:srgbClr val="FFFFFF"/>
+                </a:solidFill>
+                <a:latin typeface="Inter Text" pitchFamily="34" charset="0"/>
+                <a:ea typeface="Inter Text" pitchFamily="34" charset="-122"/>
+                <a:cs typeface="Inter Text" pitchFamily="34" charset="-120"/>
+              </a:rPr>
+              <a:t>Receivers round on import, not reject (</a:t>
+            </a:r>
+            <a:r>
+              <a:rPr lang="en-GB" sz="1250" dirty="0">
+                <a:solidFill>
+                  <a:srgbClr val="FFFFFF"/>
+                </a:solidFill>
+                <a:latin typeface="Inter Text" pitchFamily="34" charset="0"/>
+                <a:ea typeface="Inter Text" pitchFamily="34" charset="-122"/>
+                <a:cs typeface="Inter Text" pitchFamily="34" charset="-120"/>
+                <a:hlinkClick r:id="rId13">
+                  <a:extLst>
+                    <a:ext uri="{A12FA001-AC4F-418D-AE19-62706E023703}">
+                      <ahyp:hlinkClr xmlns:ahyp="http://schemas.microsoft.com/office/drawing/2018/hyperlinkcolor" val="tx"/>
+                    </a:ext>
+                  </a:extLst>
+                </a:hlinkClick>
+              </a:rPr>
+              <a:t>new Art. 232, ViDA</a:t>
+            </a:r>
+            <a:r>
+              <a:rPr lang="en-GB" sz="1250" dirty="0">
+                <a:solidFill>
+                  <a:srgbClr val="FFFFFF"/>
+                </a:solidFill>
+                <a:latin typeface="Inter Text" pitchFamily="34" charset="0"/>
+                <a:ea typeface="Inter Text" pitchFamily="34" charset="-122"/>
+                <a:cs typeface="Inter Text" pitchFamily="34" charset="-120"/>
+              </a:rPr>
+              <a:t>)</a:t>
+            </a:r>
+          </a:p>
+        </p:txBody>
+      </p:sp>
+      <p:sp>
+        <p:nvSpPr>
+          <p:cNvPr id="29" name="Shape 29"/>
+          <p:cNvSpPr/>
+          <p:nvPr/>
+        </p:nvSpPr>
+        <p:spPr>
+          <a:xfrm>
+            <a:off x="6492240" y="4645152"/>
+            <a:ext cx="292608" cy="292608"/>
+          </a:xfrm>
+          <a:prstGeom prst="ellipse">
+            <a:avLst/>
+          </a:prstGeom>
+          <a:solidFill>
+            <a:srgbClr val="19C3C8"/>
+          </a:solidFill>
+          <a:ln>
+            <a:noFill/>
+          </a:ln>
+        </p:spPr>
+        <p:txBody>
+          <a:bodyPr/>
+          <a:lstStyle/>
+          <a:p>
+            <a:endParaRPr lang="en-GB"/>
+          </a:p>
+        </p:txBody>
+      </p:sp>
+      <p:sp>
+        <p:nvSpPr>
+          <p:cNvPr id="30" name="Text 30"/>
+          <p:cNvSpPr txBox="1"/>
+          <p:nvPr/>
+        </p:nvSpPr>
+        <p:spPr>
+          <a:xfrm>
+            <a:off x="6492240" y="4645152"/>
+            <a:ext cx="292608" cy="292608"/>
+          </a:xfrm>
+          <a:prstGeom prst="rect">
+            <a:avLst/>
+          </a:prstGeom>
+          <a:noFill/>
+          <a:ln/>
+        </p:spPr>
+        <p:txBody>
+          <a:bodyPr wrap="square" lIns="0" tIns="0" rIns="0" bIns="0" rtlCol="0" anchor="ctr"/>
+          <a:lstStyle/>
+          <a:p>
+            <a:pPr marL="0" indent="0" algn="ctr">
+              <a:buNone/>
+            </a:pPr>
+            <a:r>
+              <a:rPr lang="en-GB" sz="1200" dirty="0">
+                <a:solidFill>
+                  <a:srgbClr val="1A2B5E"/>
+                </a:solidFill>
+                <a:latin typeface="Inter SemiBold Text SemiBold" pitchFamily="34" charset="0"/>
+                <a:ea typeface="Inter SemiBold Text SemiBold" pitchFamily="34" charset="-122"/>
+                <a:cs typeface="Inter SemiBold Text SemiBold" pitchFamily="34" charset="-120"/>
+              </a:rPr>
+              <a:t>✓</a:t>
+            </a:r>
+          </a:p>
+        </p:txBody>
+      </p:sp>
+      <p:sp>
+        <p:nvSpPr>
+          <p:cNvPr id="31" name="Text 31"/>
+          <p:cNvSpPr txBox="1"/>
+          <p:nvPr/>
+        </p:nvSpPr>
+        <p:spPr>
+          <a:xfrm>
+            <a:off x="6949440" y="4581144"/>
+            <a:ext cx="4251960" cy="420624"/>
+          </a:xfrm>
+          <a:prstGeom prst="rect">
+            <a:avLst/>
+          </a:prstGeom>
+          <a:noFill/>
+          <a:ln/>
+        </p:spPr>
+        <p:txBody>
+          <a:bodyPr wrap="square" lIns="0" tIns="0" rIns="0" bIns="0" rtlCol="0" anchor="ctr"/>
+          <a:lstStyle/>
+          <a:p>
+            <a:pPr marL="0" indent="0" algn="l">
+              <a:lnSpc>
+                <a:spcPct val="105000"/>
+              </a:lnSpc>
+              <a:buNone/>
+            </a:pPr>
+            <a:r>
+              <a:rPr lang="en-GB" sz="1250" dirty="0">
+                <a:solidFill>
+                  <a:srgbClr val="FFFFFF"/>
+                </a:solidFill>
+                <a:latin typeface="Inter Text" pitchFamily="34" charset="0"/>
+                <a:ea typeface="Inter Text" pitchFamily="34" charset="-122"/>
+                <a:cs typeface="Inter Text" pitchFamily="34" charset="-120"/>
+              </a:rPr>
+              <a:t>Software states its precision (decimal32, 64, 128); the market chooses</a:t>
+            </a:r>
+          </a:p>
+        </p:txBody>
+      </p:sp>
+      <p:sp>
+        <p:nvSpPr>
+          <p:cNvPr id="35" name="Pill 35"/>
+          <p:cNvSpPr/>
+          <p:nvPr/>
+        </p:nvSpPr>
+        <p:spPr>
+          <a:xfrm>
+            <a:off x="822960" y="5943600"/>
+            <a:ext cx="10543032" cy="411480"/>
+          </a:xfrm>
+          <a:prstGeom prst="roundRect">
+            <a:avLst>
+              <a:gd name="adj" fmla="val 50000"/>
+            </a:avLst>
+          </a:prstGeom>
+          <a:solidFill>
+            <a:srgbClr val="F4F6FB"/>
+          </a:solidFill>
+          <a:ln w="9525">
+            <a:solidFill>
+              <a:srgbClr val="E2E7F2"/>
+            </a:solidFill>
+            <a:prstDash val="solid"/>
+          </a:ln>
+        </p:spPr>
+        <p:txBody>
+          <a:bodyPr wrap="square" lIns="36576" tIns="36576" rIns="36576" bIns="36576" rtlCol="0" anchor="ctr"/>
+          <a:lstStyle/>
+          <a:p>
+            <a:pPr marL="0" indent="0" algn="ctr">
+              <a:buNone/>
+            </a:pPr>
+            <a:r>
+              <a:rPr lang="en-GB" sz="1100" dirty="0">
+                <a:solidFill>
+                  <a:srgbClr val="5B6890"/>
+                </a:solidFill>
+                <a:latin typeface="Inter SemiBold Text SemiBold" pitchFamily="34" charset="0"/>
+                <a:ea typeface="Inter SemiBold Text SemiBold" pitchFamily="34" charset="-122"/>
+                <a:cs typeface="Inter SemiBold Text SemiBold" pitchFamily="34" charset="-120"/>
+              </a:rPr>
+              <a:t>Conformant ≠ compliant:  </a:t>
+            </a:r>
+            <a:r>
+              <a:rPr lang="en-GB" sz="1100" dirty="0">
+                <a:solidFill>
+                  <a:srgbClr val="5B6890"/>
+                </a:solidFill>
+                <a:latin typeface="Inter Text" pitchFamily="34" charset="0"/>
+                <a:ea typeface="Inter Text" pitchFamily="34" charset="-122"/>
+                <a:cs typeface="Inter Text" pitchFamily="34" charset="-120"/>
+              </a:rPr>
+              <a:t>for the same supply, the example of </a:t>
+            </a:r>
+            <a:r>
+              <a:rPr lang="en-GB" sz="1100" dirty="0">
+                <a:solidFill>
+                  <a:srgbClr val="5B6890"/>
+                </a:solidFill>
+                <a:latin typeface="Inter Text" pitchFamily="34" charset="0"/>
+                <a:ea typeface="Inter Text" pitchFamily="34" charset="-122"/>
+                <a:cs typeface="Inter Text" pitchFamily="34" charset="-120"/>
+                <a:hlinkClick r:id="rId14">
+                  <a:extLst>
+                    <a:ext uri="{A12FA001-AC4F-418D-AE19-62706E023703}">
+                      <ahyp:hlinkClr xmlns:ahyp="http://schemas.microsoft.com/office/drawing/2018/hyperlinkcolor" val="tx"/>
+                    </a:ext>
+                  </a:extLst>
+                </a:hlinkClick>
+              </a:rPr>
+              <a:t>Paul Simons</a:t>
+            </a:r>
+            <a:r>
+              <a:rPr lang="en-GB" sz="1100" dirty="0">
+                <a:solidFill>
+                  <a:srgbClr val="5B6890"/>
+                </a:solidFill>
+                <a:latin typeface="Inter Text" pitchFamily="34" charset="0"/>
+                <a:ea typeface="Inter Text" pitchFamily="34" charset="-122"/>
+                <a:cs typeface="Inter Text" pitchFamily="34" charset="-120"/>
+              </a:rPr>
+              <a:t> gives €1.20 or €1.21; the EN tolerates it, German law has no tolerance</a:t>
+            </a:r>
+          </a:p>
+        </p:txBody>
+      </p:sp>
+      <p:sp>
+        <p:nvSpPr>
+          <p:cNvPr id="36" name="Speaker 36">
+            <a:hlinkClick r:id="rId4"/>
+          </p:cNvPr>
+          <p:cNvSpPr txBox="1"/>
+          <p:nvPr/>
+        </p:nvSpPr>
+        <p:spPr>
+          <a:xfrm>
+            <a:off x="7680960" y="6514592"/>
+            <a:ext cx="3154680" cy="292608"/>
+          </a:xfrm>
+          <a:prstGeom prst="rect">
+            <a:avLst/>
+          </a:prstGeom>
+          <a:noFill/>
+          <a:ln/>
+        </p:spPr>
+        <p:txBody>
+          <a:bodyPr wrap="square" lIns="0" tIns="0" rIns="0" bIns="0" rtlCol="0" anchor="ctr"/>
+          <a:lstStyle/>
+          <a:p>
+            <a:pPr marL="0" indent="0" algn="r">
+              <a:buNone/>
+            </a:pPr>
+            <a:r>
+              <a:rPr lang="en-GB" sz="1000" spc="100" dirty="0">
+                <a:solidFill>
+                  <a:srgbClr val="9AA4C2"/>
+                </a:solidFill>
+                <a:latin typeface="Inter Medium Text Medium" pitchFamily="34" charset="0"/>
+                <a:ea typeface="Inter Medium Text Medium" pitchFamily="34" charset="-122"/>
+                <a:cs typeface="Inter Medium Text Medium" pitchFamily="34" charset="-120"/>
+              </a:rPr>
+              <a:t>© Svante Schubert</a:t>
             </a:r>
           </a:p>
         </p:txBody>
@@ -28024,7 +29494,36 @@
                 <a:ea typeface="Inter Text" pitchFamily="34" charset="-122"/>
                 <a:cs typeface="Inter Text" pitchFamily="34" charset="-120"/>
               </a:rPr>
-              <a:t>: the VAT is paid with the VAT return, not per invoice</a:t>
+              <a:t>, </a:t>
+            </a:r>
+            <a:r>
+              <a:rPr lang="en-GB" sz="1250" dirty="0">
+                <a:solidFill>
+                  <a:srgbClr val="FFFFFF"/>
+                </a:solidFill>
+                <a:latin typeface="Inter Text" pitchFamily="34" charset="0"/>
+                <a:ea typeface="Inter Text" pitchFamily="34" charset="-122"/>
+                <a:cs typeface="Inter Text" pitchFamily="34" charset="-120"/>
+                <a:hlinkClick r:id="rId14">
+                  <a:extLst>
+                    <a:ext uri="{A12FA001-AC4F-418D-AE19-62706E023703}">
+                      <ahyp:hlinkClr xmlns:ahyp="http://schemas.microsoft.com/office/drawing/2018/hyperlinkcolor" val="tx"/>
+                    </a:ext>
+                  </a:extLst>
+                </a:hlinkClick>
+              </a:rPr>
+              <a:t>168</a:t>
+            </a:r>
+            <a:r>
+              <a:rPr lang="en-GB" sz="1250" dirty="0">
+                <a:solidFill>
+                  <a:srgbClr val="FFFFFF"/>
+                </a:solidFill>
+                <a:latin typeface="Inter Text" pitchFamily="34" charset="0"/>
+                <a:ea typeface="Inter Text" pitchFamily="34" charset="-122"/>
+                <a:cs typeface="Inter Text" pitchFamily="34" charset="-120"/>
+              </a:rPr>
+              <a:t>: the seller pays the VAT, the buyer deducts it</a:t>
             </a:r>
           </a:p>
         </p:txBody>

</xml_diff>